<commit_message>
Combine Telegram messages, sent reports and subscribers into one slide
Co-Authored-By: Claude Opus 5.5 <noreply@anthropic.com>
</commit_message>
<xml_diff>
--- a/informes/Proyectos_TI_Tracker.pptx
+++ b/informes/Proyectos_TI_Tracker.pptx
@@ -4486,7 +4486,7 @@
     </p:spTree>
     <p:extLst>
       <p:ext uri="{BB962C8B-B14F-4D97-AF65-F5344CB8AC3E}">
-        <p14:creationId xmlns:p14="http://schemas.microsoft.com/office/powerpoint/2010/main" val="525721580"/>
+        <p14:creationId xmlns:p14="http://schemas.microsoft.com/office/powerpoint/2010/main" val="3410096644"/>
       </p:ext>
     </p:extLst>
   </p:cSld>
@@ -4557,7 +4557,7 @@
           <p:cNvPr id="3" name="Picture 2">
             <a:extLst>
               <a:ext uri="{FF2B5EF4-FFF2-40B4-BE49-F238E27FC236}">
-                <a16:creationId xmlns:a16="http://schemas.microsoft.com/office/drawing/2014/main" id="{6CAD6388-1B8D-194E-4ED5-F0C9531D6A67}"/>
+                <a16:creationId xmlns:a16="http://schemas.microsoft.com/office/drawing/2014/main" id="{5CF3B860-7AA5-9D15-20EF-0EAB12F2FBA7}"/>
               </a:ext>
             </a:extLst>
           </p:cNvPr>
@@ -4781,7 +4781,7 @@
           <p:cNvPr id="5" name="Picture 4">
             <a:extLst>
               <a:ext uri="{FF2B5EF4-FFF2-40B4-BE49-F238E27FC236}">
-                <a16:creationId xmlns:a16="http://schemas.microsoft.com/office/drawing/2014/main" id="{59EB7A1C-0ED4-E0E0-3359-F907FAA095B8}"/>
+                <a16:creationId xmlns:a16="http://schemas.microsoft.com/office/drawing/2014/main" id="{34E5B4CA-75EA-6C11-0CDA-B915E02F4274}"/>
               </a:ext>
             </a:extLst>
           </p:cNvPr>
@@ -4931,7 +4931,7 @@
           <p:cNvPr id="7" name="Picture 6">
             <a:extLst>
               <a:ext uri="{FF2B5EF4-FFF2-40B4-BE49-F238E27FC236}">
-                <a16:creationId xmlns:a16="http://schemas.microsoft.com/office/drawing/2014/main" id="{74CF0B89-5BBF-E5DF-3479-FD6CC10BEA61}"/>
+                <a16:creationId xmlns:a16="http://schemas.microsoft.com/office/drawing/2014/main" id="{CFC80000-5040-1FC3-18C4-0E6C3DC12CFF}"/>
               </a:ext>
             </a:extLst>
           </p:cNvPr>
@@ -5099,7 +5099,7 @@
           <p:cNvPr id="9" name="Picture 8">
             <a:extLst>
               <a:ext uri="{FF2B5EF4-FFF2-40B4-BE49-F238E27FC236}">
-                <a16:creationId xmlns:a16="http://schemas.microsoft.com/office/drawing/2014/main" id="{6946BE0B-4516-9A6B-87BB-6EEB23D8C7F5}"/>
+                <a16:creationId xmlns:a16="http://schemas.microsoft.com/office/drawing/2014/main" id="{F578905D-39A4-CA01-3828-DD7A1D071EC3}"/>
               </a:ext>
             </a:extLst>
           </p:cNvPr>
@@ -5267,7 +5267,7 @@
           <p:cNvPr id="11" name="Picture 10">
             <a:extLst>
               <a:ext uri="{FF2B5EF4-FFF2-40B4-BE49-F238E27FC236}">
-                <a16:creationId xmlns:a16="http://schemas.microsoft.com/office/drawing/2014/main" id="{7446B3FB-6D9E-8791-440A-3D2C27A67083}"/>
+                <a16:creationId xmlns:a16="http://schemas.microsoft.com/office/drawing/2014/main" id="{C82A8217-7C37-9300-3F0B-DD81D0A2C9BD}"/>
               </a:ext>
             </a:extLst>
           </p:cNvPr>
@@ -5723,7 +5723,7 @@
           <p:cNvPr id="12" name="TextBox 11">
             <a:extLst>
               <a:ext uri="{FF2B5EF4-FFF2-40B4-BE49-F238E27FC236}">
-                <a16:creationId xmlns:a16="http://schemas.microsoft.com/office/drawing/2014/main" id="{FCEB862C-23E5-8D6A-42F0-A3E4A29E03AC}"/>
+                <a16:creationId xmlns:a16="http://schemas.microsoft.com/office/drawing/2014/main" id="{7DB24834-0664-457E-7AF2-2F91D7E2163F}"/>
               </a:ext>
             </a:extLst>
           </p:cNvPr>
@@ -5785,7 +5785,7 @@
           <p:cNvPr id="13" name="TextBox 12">
             <a:extLst>
               <a:ext uri="{FF2B5EF4-FFF2-40B4-BE49-F238E27FC236}">
-                <a16:creationId xmlns:a16="http://schemas.microsoft.com/office/drawing/2014/main" id="{F98C5489-3B9D-ADAE-5271-820B8E5709C5}"/>
+                <a16:creationId xmlns:a16="http://schemas.microsoft.com/office/drawing/2014/main" id="{92A9FF23-2E29-0DE7-C2EB-B1F2927460E5}"/>
               </a:ext>
             </a:extLst>
           </p:cNvPr>
@@ -5847,7 +5847,7 @@
           <p:cNvPr id="14" name="TextBox 13">
             <a:extLst>
               <a:ext uri="{FF2B5EF4-FFF2-40B4-BE49-F238E27FC236}">
-                <a16:creationId xmlns:a16="http://schemas.microsoft.com/office/drawing/2014/main" id="{FCA56E86-1182-FAD8-1355-4512FE1E184C}"/>
+                <a16:creationId xmlns:a16="http://schemas.microsoft.com/office/drawing/2014/main" id="{97AF6AC3-8114-B98F-0830-4AA81FB83033}"/>
               </a:ext>
             </a:extLst>
           </p:cNvPr>
@@ -5886,7 +5886,7 @@
     </p:spTree>
     <p:extLst>
       <p:ext uri="{BB962C8B-B14F-4D97-AF65-F5344CB8AC3E}">
-        <p14:creationId xmlns:p14="http://schemas.microsoft.com/office/powerpoint/2010/main" val="3038516671"/>
+        <p14:creationId xmlns:p14="http://schemas.microsoft.com/office/powerpoint/2010/main" val="2754533084"/>
       </p:ext>
     </p:extLst>
   </p:cSld>
@@ -5957,7 +5957,7 @@
           <p:cNvPr id="3" name="Picture 2">
             <a:extLst>
               <a:ext uri="{FF2B5EF4-FFF2-40B4-BE49-F238E27FC236}">
-                <a16:creationId xmlns:a16="http://schemas.microsoft.com/office/drawing/2014/main" id="{CEBFD731-0F20-CC9B-E857-B0AEE945F389}"/>
+                <a16:creationId xmlns:a16="http://schemas.microsoft.com/office/drawing/2014/main" id="{4CCB02BB-F7ED-3981-7FFA-BA3198BE44AF}"/>
               </a:ext>
             </a:extLst>
           </p:cNvPr>
@@ -6257,7 +6257,7 @@
           <p:cNvPr id="5" name="Picture 4">
             <a:extLst>
               <a:ext uri="{FF2B5EF4-FFF2-40B4-BE49-F238E27FC236}">
-                <a16:creationId xmlns:a16="http://schemas.microsoft.com/office/drawing/2014/main" id="{1E727FA1-0BF1-053E-4878-404E9CAB03B5}"/>
+                <a16:creationId xmlns:a16="http://schemas.microsoft.com/office/drawing/2014/main" id="{AD72EBA4-5EE5-F66B-357B-6C3328EB8CCC}"/>
               </a:ext>
             </a:extLst>
           </p:cNvPr>
@@ -6564,7 +6564,7 @@
           <p:cNvPr id="7" name="Picture 6">
             <a:extLst>
               <a:ext uri="{FF2B5EF4-FFF2-40B4-BE49-F238E27FC236}">
-                <a16:creationId xmlns:a16="http://schemas.microsoft.com/office/drawing/2014/main" id="{FFF288AF-BE3A-465D-1C0D-8D5E7C9C3C00}"/>
+                <a16:creationId xmlns:a16="http://schemas.microsoft.com/office/drawing/2014/main" id="{908595F9-4A30-CBF1-E4D9-A970A0B8345B}"/>
               </a:ext>
             </a:extLst>
           </p:cNvPr>
@@ -7672,7 +7672,7 @@
           <p:cNvPr id="8" name="TextBox 7">
             <a:extLst>
               <a:ext uri="{FF2B5EF4-FFF2-40B4-BE49-F238E27FC236}">
-                <a16:creationId xmlns:a16="http://schemas.microsoft.com/office/drawing/2014/main" id="{D1B747B1-EC96-F53D-A71F-C7B116CB1D5B}"/>
+                <a16:creationId xmlns:a16="http://schemas.microsoft.com/office/drawing/2014/main" id="{9794D54F-DCAF-3FEE-1DA2-4F36DBAF67FB}"/>
               </a:ext>
             </a:extLst>
           </p:cNvPr>
@@ -7734,7 +7734,7 @@
           <p:cNvPr id="9" name="TextBox 8">
             <a:extLst>
               <a:ext uri="{FF2B5EF4-FFF2-40B4-BE49-F238E27FC236}">
-                <a16:creationId xmlns:a16="http://schemas.microsoft.com/office/drawing/2014/main" id="{448B5F1F-6B55-605D-E3EC-7D9A8C687C28}"/>
+                <a16:creationId xmlns:a16="http://schemas.microsoft.com/office/drawing/2014/main" id="{12C94AAE-C397-14A3-4299-61D4E1D63A78}"/>
               </a:ext>
             </a:extLst>
           </p:cNvPr>
@@ -7796,7 +7796,7 @@
           <p:cNvPr id="10" name="TextBox 9">
             <a:extLst>
               <a:ext uri="{FF2B5EF4-FFF2-40B4-BE49-F238E27FC236}">
-                <a16:creationId xmlns:a16="http://schemas.microsoft.com/office/drawing/2014/main" id="{2E10C29F-7A9E-38E2-66B4-9B8B5CEAA540}"/>
+                <a16:creationId xmlns:a16="http://schemas.microsoft.com/office/drawing/2014/main" id="{41D865D2-E3DF-0EB5-C6E4-1F13E4779541}"/>
               </a:ext>
             </a:extLst>
           </p:cNvPr>
@@ -7835,7 +7835,7 @@
     </p:spTree>
     <p:extLst>
       <p:ext uri="{BB962C8B-B14F-4D97-AF65-F5344CB8AC3E}">
-        <p14:creationId xmlns:p14="http://schemas.microsoft.com/office/powerpoint/2010/main" val="1044205299"/>
+        <p14:creationId xmlns:p14="http://schemas.microsoft.com/office/powerpoint/2010/main" val="1770755497"/>
       </p:ext>
     </p:extLst>
   </p:cSld>
@@ -7906,7 +7906,7 @@
           <p:cNvPr id="3" name="Picture 2">
             <a:extLst>
               <a:ext uri="{FF2B5EF4-FFF2-40B4-BE49-F238E27FC236}">
-                <a16:creationId xmlns:a16="http://schemas.microsoft.com/office/drawing/2014/main" id="{EB7DC109-D258-BAB9-21B6-D0253E399A9B}"/>
+                <a16:creationId xmlns:a16="http://schemas.microsoft.com/office/drawing/2014/main" id="{3341928D-41F0-5A02-6265-456804A5F5F1}"/>
               </a:ext>
             </a:extLst>
           </p:cNvPr>
@@ -8814,7 +8814,7 @@
           <p:cNvPr id="4" name="Shape">
             <a:extLst>
               <a:ext uri="{FF2B5EF4-FFF2-40B4-BE49-F238E27FC236}">
-                <a16:creationId xmlns:a16="http://schemas.microsoft.com/office/drawing/2014/main" id="{533BB03B-D088-ECD9-0D29-2DCEE4796A50}"/>
+                <a16:creationId xmlns:a16="http://schemas.microsoft.com/office/drawing/2014/main" id="{17A237FD-3DF8-7A51-FDF6-CC0A8B71B876}"/>
               </a:ext>
             </a:extLst>
           </p:cNvPr>
@@ -8861,7 +8861,7 @@
           <p:cNvPr id="5" name="Shape">
             <a:extLst>
               <a:ext uri="{FF2B5EF4-FFF2-40B4-BE49-F238E27FC236}">
-                <a16:creationId xmlns:a16="http://schemas.microsoft.com/office/drawing/2014/main" id="{5EA0D9DA-BE45-D6EB-BE25-5A0F7BF0C2B4}"/>
+                <a16:creationId xmlns:a16="http://schemas.microsoft.com/office/drawing/2014/main" id="{396041B9-5617-47FD-28FA-D1E22A9ABDE3}"/>
               </a:ext>
             </a:extLst>
           </p:cNvPr>
@@ -8908,7 +8908,7 @@
           <p:cNvPr id="8" name="Picture 7">
             <a:extLst>
               <a:ext uri="{FF2B5EF4-FFF2-40B4-BE49-F238E27FC236}">
-                <a16:creationId xmlns:a16="http://schemas.microsoft.com/office/drawing/2014/main" id="{465B1A7D-5EC1-2E3D-3B5E-83D5678D2682}"/>
+                <a16:creationId xmlns:a16="http://schemas.microsoft.com/office/drawing/2014/main" id="{881E98ED-DEFA-3748-D328-8F74CE46552D}"/>
               </a:ext>
             </a:extLst>
           </p:cNvPr>
@@ -8939,7 +8939,7 @@
           <p:cNvPr id="11" name="Picture 10">
             <a:extLst>
               <a:ext uri="{FF2B5EF4-FFF2-40B4-BE49-F238E27FC236}">
-                <a16:creationId xmlns:a16="http://schemas.microsoft.com/office/drawing/2014/main" id="{22CFFF88-AF8D-E5A3-E456-D894D48A3A80}"/>
+                <a16:creationId xmlns:a16="http://schemas.microsoft.com/office/drawing/2014/main" id="{6227DBFD-4042-FEBC-49D0-6D2047FC2B49}"/>
               </a:ext>
             </a:extLst>
           </p:cNvPr>
@@ -9177,7 +9177,7 @@
           <p:cNvPr id="12" name="Oval 11">
             <a:extLst>
               <a:ext uri="{FF2B5EF4-FFF2-40B4-BE49-F238E27FC236}">
-                <a16:creationId xmlns:a16="http://schemas.microsoft.com/office/drawing/2014/main" id="{F5600881-3DF7-A857-93A9-7F4AD5C97298}"/>
+                <a16:creationId xmlns:a16="http://schemas.microsoft.com/office/drawing/2014/main" id="{B574C2AD-A13B-6794-D877-6419F922D70F}"/>
               </a:ext>
             </a:extLst>
           </p:cNvPr>
@@ -9231,7 +9231,7 @@
           <p:cNvPr id="13" name="TextBox 12">
             <a:extLst>
               <a:ext uri="{FF2B5EF4-FFF2-40B4-BE49-F238E27FC236}">
-                <a16:creationId xmlns:a16="http://schemas.microsoft.com/office/drawing/2014/main" id="{7D563D19-BFC7-D181-FF08-B2316E41842D}"/>
+                <a16:creationId xmlns:a16="http://schemas.microsoft.com/office/drawing/2014/main" id="{30EF6DAA-5F26-C065-9E27-E5ECCBEFFAD1}"/>
               </a:ext>
             </a:extLst>
           </p:cNvPr>
@@ -9271,7 +9271,7 @@
           <p:cNvPr id="14" name="Oval 13">
             <a:extLst>
               <a:ext uri="{FF2B5EF4-FFF2-40B4-BE49-F238E27FC236}">
-                <a16:creationId xmlns:a16="http://schemas.microsoft.com/office/drawing/2014/main" id="{41D4CA4D-C891-CE65-D0E9-F7840C9C1127}"/>
+                <a16:creationId xmlns:a16="http://schemas.microsoft.com/office/drawing/2014/main" id="{039A67DA-64D7-A5DE-F7BF-48272CBBE3C8}"/>
               </a:ext>
             </a:extLst>
           </p:cNvPr>
@@ -9325,7 +9325,7 @@
           <p:cNvPr id="15" name="TextBox 14">
             <a:extLst>
               <a:ext uri="{FF2B5EF4-FFF2-40B4-BE49-F238E27FC236}">
-                <a16:creationId xmlns:a16="http://schemas.microsoft.com/office/drawing/2014/main" id="{9538277C-7068-8DB8-1EAA-E90B20C6F070}"/>
+                <a16:creationId xmlns:a16="http://schemas.microsoft.com/office/drawing/2014/main" id="{B56D6D1A-6308-DDE4-0E87-F2CBE76B3CB6}"/>
               </a:ext>
             </a:extLst>
           </p:cNvPr>
@@ -9365,7 +9365,7 @@
           <p:cNvPr id="16" name="Oval 15">
             <a:extLst>
               <a:ext uri="{FF2B5EF4-FFF2-40B4-BE49-F238E27FC236}">
-                <a16:creationId xmlns:a16="http://schemas.microsoft.com/office/drawing/2014/main" id="{D88914B1-2C17-AE42-8E65-B6E5EF719D71}"/>
+                <a16:creationId xmlns:a16="http://schemas.microsoft.com/office/drawing/2014/main" id="{293EB355-ED50-7A7C-A4AC-83E2332AD38B}"/>
               </a:ext>
             </a:extLst>
           </p:cNvPr>
@@ -9419,7 +9419,7 @@
           <p:cNvPr id="17" name="TextBox 16">
             <a:extLst>
               <a:ext uri="{FF2B5EF4-FFF2-40B4-BE49-F238E27FC236}">
-                <a16:creationId xmlns:a16="http://schemas.microsoft.com/office/drawing/2014/main" id="{706C5A02-CEEE-B437-A37A-A3FCBF2BD94C}"/>
+                <a16:creationId xmlns:a16="http://schemas.microsoft.com/office/drawing/2014/main" id="{5CF1ECF8-8685-DD57-63EB-4EC9C56E9613}"/>
               </a:ext>
             </a:extLst>
           </p:cNvPr>
@@ -9459,7 +9459,7 @@
           <p:cNvPr id="18" name="Straight Connector 17">
             <a:extLst>
               <a:ext uri="{FF2B5EF4-FFF2-40B4-BE49-F238E27FC236}">
-                <a16:creationId xmlns:a16="http://schemas.microsoft.com/office/drawing/2014/main" id="{E53016FC-3D27-81AE-2608-30D9C769DE26}"/>
+                <a16:creationId xmlns:a16="http://schemas.microsoft.com/office/drawing/2014/main" id="{EC0F6274-1773-3ED5-5711-4568977584C5}"/>
               </a:ext>
             </a:extLst>
           </p:cNvPr>
@@ -9500,7 +9500,7 @@
           <p:cNvPr id="19" name="TextBox 18">
             <a:extLst>
               <a:ext uri="{FF2B5EF4-FFF2-40B4-BE49-F238E27FC236}">
-                <a16:creationId xmlns:a16="http://schemas.microsoft.com/office/drawing/2014/main" id="{44A281A6-B38D-8A48-B7D0-6A088B1D798C}"/>
+                <a16:creationId xmlns:a16="http://schemas.microsoft.com/office/drawing/2014/main" id="{DE475757-D7E8-BD53-620E-F3B0D5C03807}"/>
               </a:ext>
             </a:extLst>
           </p:cNvPr>
@@ -9544,7 +9544,7 @@
     </p:spTree>
     <p:extLst>
       <p:ext uri="{BB962C8B-B14F-4D97-AF65-F5344CB8AC3E}">
-        <p14:creationId xmlns:p14="http://schemas.microsoft.com/office/powerpoint/2010/main" val="3584894120"/>
+        <p14:creationId xmlns:p14="http://schemas.microsoft.com/office/powerpoint/2010/main" val="3668101797"/>
       </p:ext>
     </p:extLst>
   </p:cSld>
@@ -9615,7 +9615,7 @@
           <p:cNvPr id="3" name="Picture 2">
             <a:extLst>
               <a:ext uri="{FF2B5EF4-FFF2-40B4-BE49-F238E27FC236}">
-                <a16:creationId xmlns:a16="http://schemas.microsoft.com/office/drawing/2014/main" id="{AAD3F427-2399-81E5-3953-A98F608D1812}"/>
+                <a16:creationId xmlns:a16="http://schemas.microsoft.com/office/drawing/2014/main" id="{0D92F574-9E14-530D-CA23-D88B7B553F38}"/>
               </a:ext>
             </a:extLst>
           </p:cNvPr>
@@ -9839,7 +9839,7 @@
           <p:cNvPr id="5" name="Picture 4">
             <a:extLst>
               <a:ext uri="{FF2B5EF4-FFF2-40B4-BE49-F238E27FC236}">
-                <a16:creationId xmlns:a16="http://schemas.microsoft.com/office/drawing/2014/main" id="{7A7CBB2F-D6ED-065C-5A8C-C0231AAF2530}"/>
+                <a16:creationId xmlns:a16="http://schemas.microsoft.com/office/drawing/2014/main" id="{40A93C4D-8F91-6225-DC88-0EAD5C3FD1EB}"/>
               </a:ext>
             </a:extLst>
           </p:cNvPr>
@@ -10551,7 +10551,7 @@
     </p:spTree>
     <p:extLst>
       <p:ext uri="{BB962C8B-B14F-4D97-AF65-F5344CB8AC3E}">
-        <p14:creationId xmlns:p14="http://schemas.microsoft.com/office/powerpoint/2010/main" val="3612003818"/>
+        <p14:creationId xmlns:p14="http://schemas.microsoft.com/office/powerpoint/2010/main" val="681832610"/>
       </p:ext>
     </p:extLst>
   </p:cSld>
@@ -10563,7 +10563,7 @@
 
 <file path=ppt/slides/slide17.xml><?xml version="1.0" encoding="utf-8"?>
 <p:sld xmlns:a="http://schemas.openxmlformats.org/drawingml/2006/main" xmlns:r="http://schemas.openxmlformats.org/officeDocument/2006/relationships" xmlns:p="http://schemas.openxmlformats.org/presentationml/2006/main">
-  <p:cSld name="Combustible">
+  <p:cSld name="Reportes Combustible">
     <p:bg>
       <p:bgPr>
         <a:solidFill>
@@ -10622,7 +10622,7 @@
           <p:cNvPr id="3" name="Picture 2">
             <a:extLst>
               <a:ext uri="{FF2B5EF4-FFF2-40B4-BE49-F238E27FC236}">
-                <a16:creationId xmlns:a16="http://schemas.microsoft.com/office/drawing/2014/main" id="{31FA408B-14CB-C88E-787E-F73743FC9524}"/>
+                <a16:creationId xmlns:a16="http://schemas.microsoft.com/office/drawing/2014/main" id="{0DE3519C-5F47-7C5C-8956-301AE2800665}"/>
               </a:ext>
             </a:extLst>
           </p:cNvPr>
@@ -10671,7 +10671,7 @@
               <a:buNone/>
             </a:pPr>
             <a:r>
-              <a:rPr lang="es-VE" sz="2500" b="1">
+              <a:rPr lang="es-ES" sz="2500" b="1">
                 <a:solidFill>
                   <a:srgbClr val="0E2438"/>
                 </a:solidFill>
@@ -10679,7 +10679,7 @@
                 <a:ea typeface="Cambria" pitchFamily="34" charset="-122"/>
                 <a:cs typeface="Cambria" pitchFamily="34" charset="-120"/>
               </a:rPr>
-              <a:t>Tracker GPS · Telegram</a:t>
+              <a:t>Tracker GPS · Telegram: Mensajes y Acceso</a:t>
             </a:r>
             <a:endParaRPr lang="es-VE" sz="2500" b="1" dirty="0">
               <a:solidFill>
@@ -10808,8 +10808,8 @@
         </p:nvSpPr>
         <p:spPr>
           <a:xfrm>
-            <a:off x="457200" y="1143000"/>
-            <a:ext cx="7589520" cy="3732169"/>
+            <a:off x="3251200" y="1117600"/>
+            <a:ext cx="4572000" cy="2133600"/>
           </a:xfrm>
           <a:prstGeom prst="roundRect">
             <a:avLst>
@@ -10843,10 +10843,10 @@
       </p:sp>
       <p:pic>
         <p:nvPicPr>
-          <p:cNvPr id="5" name="Picture 4">
+          <p:cNvPr id="10" name="Picture 9">
             <a:extLst>
               <a:ext uri="{FF2B5EF4-FFF2-40B4-BE49-F238E27FC236}">
-                <a16:creationId xmlns:a16="http://schemas.microsoft.com/office/drawing/2014/main" id="{533B5327-56C0-56C7-21DC-561BC9D7EDDF}"/>
+                <a16:creationId xmlns:a16="http://schemas.microsoft.com/office/drawing/2014/main" id="{347013B1-5B16-1216-56C2-F80F01D0990E}"/>
               </a:ext>
             </a:extLst>
           </p:cNvPr>
@@ -10857,15 +10857,15 @@
         </p:nvPicPr>
         <p:blipFill>
           <a:blip r:embed="rId3"/>
-          <a:srcRect r="68"/>
+          <a:srcRect b="844"/>
           <a:stretch>
             <a:fillRect/>
           </a:stretch>
         </p:blipFill>
         <p:spPr>
           <a:xfrm>
-            <a:off x="530352" y="1216153"/>
-            <a:ext cx="7443216" cy="3585865"/>
+            <a:off x="3327400" y="1193800"/>
+            <a:ext cx="4419600" cy="1981200"/>
           </a:xfrm>
           <a:prstGeom prst="rect">
             <a:avLst/>
@@ -10880,8 +10880,8 @@
         </p:nvSpPr>
         <p:spPr>
           <a:xfrm>
-            <a:off x="530352" y="4966609"/>
-            <a:ext cx="7589520" cy="237744"/>
+            <a:off x="3327400" y="3302000"/>
+            <a:ext cx="4572000" cy="237744"/>
           </a:xfrm>
           <a:prstGeom prst="rect">
             <a:avLst/>
@@ -10904,7 +10904,7 @@
                 <a:ea typeface="Calibri" pitchFamily="34" charset="-122"/>
                 <a:cs typeface="Calibri" pitchFamily="34" charset="-120"/>
               </a:rPr>
-              <a:t>SUSCRIPTORES DE TELEGRAM</a:t>
+              <a:t>REPORTE ENVIADO A TELEGRAM</a:t>
             </a:r>
             <a:r>
               <a:rPr lang="es-ES" sz="1050" spc="100">
@@ -10915,7 +10915,7 @@
                 <a:ea typeface="Calibri" pitchFamily="34" charset="-122"/>
                 <a:cs typeface="Calibri" pitchFamily="34" charset="-120"/>
               </a:rPr>
-              <a:t> — acceso al bot con aprobación</a:t>
+              <a:t> — cada envío con su PDF</a:t>
             </a:r>
             <a:endParaRPr lang="es-VE" sz="1050" spc="100" dirty="0">
               <a:solidFill>
@@ -10930,18 +10930,599 @@
       </p:sp>
       <p:sp>
         <p:nvSpPr>
-          <p:cNvPr id="110" name="Shape"/>
+          <p:cNvPr id="110" name="Text"/>
+          <p:cNvSpPr txBox="1"/>
+          <p:nvPr/>
+        </p:nvSpPr>
+        <p:spPr>
+          <a:xfrm>
+            <a:off x="8077200" y="1092200"/>
+            <a:ext cx="3657600" cy="256032"/>
+          </a:xfrm>
+          <a:prstGeom prst="rect">
+            <a:avLst/>
+          </a:prstGeom>
+          <a:noFill/>
+        </p:spPr>
+        <p:txBody>
+          <a:bodyPr wrap="square" lIns="0" tIns="0" rIns="0" bIns="0" rtlCol="0" anchor="ctr"/>
+          <a:lstStyle/>
+          <a:p>
+            <a:pPr marL="0" indent="0" algn="l">
+              <a:buNone/>
+            </a:pPr>
+            <a:r>
+              <a:rPr lang="es-VE" sz="1050" b="1" spc="150">
+                <a:solidFill>
+                  <a:srgbClr val="D99B0A"/>
+                </a:solidFill>
+                <a:latin typeface="Calibri" pitchFamily="34" charset="0"/>
+                <a:ea typeface="Calibri" pitchFamily="34" charset="-122"/>
+                <a:cs typeface="Calibri" pitchFamily="34" charset="-120"/>
+              </a:rPr>
+              <a:t>CONTROL Y SEGURIDAD</a:t>
+            </a:r>
+            <a:endParaRPr lang="es-VE" sz="1050" b="1" spc="150" dirty="0">
+              <a:solidFill>
+                <a:srgbClr val="D99B0A"/>
+              </a:solidFill>
+              <a:latin typeface="Calibri" pitchFamily="34" charset="0"/>
+              <a:ea typeface="Calibri" pitchFamily="34" charset="-122"/>
+              <a:cs typeface="Calibri" pitchFamily="34" charset="-120"/>
+            </a:endParaRPr>
+          </a:p>
+        </p:txBody>
+      </p:sp>
+      <p:sp>
+        <p:nvSpPr>
+          <p:cNvPr id="113" name="Shape"/>
           <p:cNvSpPr/>
           <p:nvPr/>
         </p:nvSpPr>
         <p:spPr>
           <a:xfrm>
-            <a:off x="457200" y="5378089"/>
-            <a:ext cx="2438400" cy="1005840"/>
+            <a:off x="8077200" y="1397000"/>
+            <a:ext cx="3657600" cy="736600"/>
+          </a:xfrm>
+          <a:prstGeom prst="roundRect">
+            <a:avLst>
+              <a:gd name="adj" fmla="val 8000"/>
+            </a:avLst>
+          </a:prstGeom>
+          <a:solidFill>
+            <a:srgbClr val="F7FAFC"/>
+          </a:solidFill>
+          <a:ln w="12700">
+            <a:solidFill>
+              <a:srgbClr val="DDE3EA"/>
+            </a:solidFill>
+            <a:prstDash val="solid"/>
+          </a:ln>
+        </p:spPr>
+        <p:txBody>
+          <a:bodyPr/>
+          <a:lstStyle/>
+          <a:p>
+            <a:endParaRPr lang="en-US"/>
+          </a:p>
+        </p:txBody>
+      </p:sp>
+      <p:sp>
+        <p:nvSpPr>
+          <p:cNvPr id="114" name="Shape"/>
+          <p:cNvSpPr/>
+          <p:nvPr/>
+        </p:nvSpPr>
+        <p:spPr>
+          <a:xfrm>
+            <a:off x="8216900" y="1536700"/>
+            <a:ext cx="292608" cy="292608"/>
+          </a:xfrm>
+          <a:prstGeom prst="ellipse">
+            <a:avLst/>
+          </a:prstGeom>
+          <a:solidFill>
+            <a:srgbClr val="1E4D6B"/>
+          </a:solidFill>
+          <a:ln>
+            <a:noFill/>
+          </a:ln>
+        </p:spPr>
+        <p:txBody>
+          <a:bodyPr/>
+          <a:lstStyle/>
+          <a:p>
+            <a:endParaRPr lang="en-US"/>
+          </a:p>
+        </p:txBody>
+      </p:sp>
+      <p:pic>
+        <p:nvPicPr>
+          <p:cNvPr id="25" name="Picture 24">
+            <a:extLst>
+              <a:ext uri="{FF2B5EF4-FFF2-40B4-BE49-F238E27FC236}">
+                <a16:creationId xmlns:a16="http://schemas.microsoft.com/office/drawing/2014/main" id="{02BEC6A6-BC93-BCB4-26D4-71588ABAD5BB}"/>
+              </a:ext>
+            </a:extLst>
+          </p:cNvPr>
+          <p:cNvPicPr>
+            <a:picLocks/>
+          </p:cNvPicPr>
+          <p:nvPr/>
+        </p:nvPicPr>
+        <p:blipFill>
+          <a:blip r:embed="rId4"/>
+          <a:stretch>
+            <a:fillRect/>
+          </a:stretch>
+        </p:blipFill>
+        <p:spPr>
+          <a:xfrm>
+            <a:off x="8280400" y="1593850"/>
+            <a:ext cx="182880" cy="182880"/>
+          </a:xfrm>
+          <a:prstGeom prst="rect">
+            <a:avLst/>
+          </a:prstGeom>
+        </p:spPr>
+      </p:pic>
+      <p:sp>
+        <p:nvSpPr>
+          <p:cNvPr id="116" name="Text"/>
+          <p:cNvSpPr txBox="1"/>
+          <p:nvPr/>
+        </p:nvSpPr>
+        <p:spPr>
+          <a:xfrm>
+            <a:off x="8636000" y="1485900"/>
+            <a:ext cx="2971800" cy="558800"/>
+          </a:xfrm>
+          <a:prstGeom prst="rect">
+            <a:avLst/>
+          </a:prstGeom>
+          <a:noFill/>
+        </p:spPr>
+        <p:txBody>
+          <a:bodyPr wrap="square" lIns="0" tIns="0" rIns="0" bIns="0" rtlCol="0" anchor="ctr"/>
+          <a:lstStyle/>
+          <a:p>
+            <a:pPr marL="0" indent="0" algn="l">
+              <a:spcAft>
+                <a:spcPts val="100"/>
+              </a:spcAft>
+              <a:buNone/>
+            </a:pPr>
+            <a:r>
+              <a:rPr lang="es-VE" sz="1150" b="1">
+                <a:solidFill>
+                  <a:srgbClr val="0E2438"/>
+                </a:solidFill>
+                <a:latin typeface="Cambria" pitchFamily="34" charset="0"/>
+                <a:ea typeface="Cambria" pitchFamily="34" charset="-122"/>
+                <a:cs typeface="Cambria" pitchFamily="34" charset="-120"/>
+              </a:rPr>
+              <a:t>Solo personas aprobadas</a:t>
+            </a:r>
+            <a:endParaRPr lang="es-VE" sz="1150" b="1" dirty="0">
+              <a:solidFill>
+                <a:srgbClr val="0E2438"/>
+              </a:solidFill>
+              <a:latin typeface="Cambria" pitchFamily="34" charset="0"/>
+              <a:ea typeface="Cambria" pitchFamily="34" charset="-122"/>
+              <a:cs typeface="Cambria" pitchFamily="34" charset="-120"/>
+            </a:endParaRPr>
+          </a:p>
+          <a:p>
+            <a:pPr marL="0" indent="0" algn="l">
+              <a:lnSpc>
+                <a:spcPct val="100000"/>
+              </a:lnSpc>
+              <a:buNone/>
+            </a:pPr>
+            <a:r>
+              <a:rPr lang="es-ES" sz="950">
+                <a:solidFill>
+                  <a:srgbClr val="7C8B99"/>
+                </a:solidFill>
+                <a:latin typeface="Calibri" pitchFamily="34" charset="0"/>
+                <a:ea typeface="Calibri" pitchFamily="34" charset="-122"/>
+                <a:cs typeface="Calibri" pitchFamily="34" charset="-120"/>
+              </a:rPr>
+              <a:t>Quien escribe al bot queda pendiente hasta que se aprueba.</a:t>
+            </a:r>
+            <a:endParaRPr lang="es-VE" sz="950" dirty="0">
+              <a:solidFill>
+                <a:srgbClr val="7C8B99"/>
+              </a:solidFill>
+              <a:latin typeface="Calibri" pitchFamily="34" charset="0"/>
+              <a:ea typeface="Calibri" pitchFamily="34" charset="-122"/>
+              <a:cs typeface="Calibri" pitchFamily="34" charset="-120"/>
+            </a:endParaRPr>
+          </a:p>
+        </p:txBody>
+      </p:sp>
+      <p:sp>
+        <p:nvSpPr>
+          <p:cNvPr id="117" name="Shape"/>
+          <p:cNvSpPr/>
+          <p:nvPr/>
+        </p:nvSpPr>
+        <p:spPr>
+          <a:xfrm>
+            <a:off x="8077200" y="2209800"/>
+            <a:ext cx="3657600" cy="736600"/>
+          </a:xfrm>
+          <a:prstGeom prst="roundRect">
+            <a:avLst>
+              <a:gd name="adj" fmla="val 8000"/>
+            </a:avLst>
+          </a:prstGeom>
+          <a:solidFill>
+            <a:srgbClr val="F7FAFC"/>
+          </a:solidFill>
+          <a:ln w="12700">
+            <a:solidFill>
+              <a:srgbClr val="DDE3EA"/>
+            </a:solidFill>
+            <a:prstDash val="solid"/>
+          </a:ln>
+        </p:spPr>
+        <p:txBody>
+          <a:bodyPr/>
+          <a:lstStyle/>
+          <a:p>
+            <a:endParaRPr lang="en-US"/>
+          </a:p>
+        </p:txBody>
+      </p:sp>
+      <p:sp>
+        <p:nvSpPr>
+          <p:cNvPr id="118" name="Shape"/>
+          <p:cNvSpPr/>
+          <p:nvPr/>
+        </p:nvSpPr>
+        <p:spPr>
+          <a:xfrm>
+            <a:off x="8216900" y="2349500"/>
+            <a:ext cx="292608" cy="292608"/>
+          </a:xfrm>
+          <a:prstGeom prst="ellipse">
+            <a:avLst/>
+          </a:prstGeom>
+          <a:solidFill>
+            <a:srgbClr val="1E4D6B"/>
+          </a:solidFill>
+          <a:ln>
+            <a:noFill/>
+          </a:ln>
+        </p:spPr>
+        <p:txBody>
+          <a:bodyPr/>
+          <a:lstStyle/>
+          <a:p>
+            <a:endParaRPr lang="en-US"/>
+          </a:p>
+        </p:txBody>
+      </p:sp>
+      <p:pic>
+        <p:nvPicPr>
+          <p:cNvPr id="27" name="Picture 26">
+            <a:extLst>
+              <a:ext uri="{FF2B5EF4-FFF2-40B4-BE49-F238E27FC236}">
+                <a16:creationId xmlns:a16="http://schemas.microsoft.com/office/drawing/2014/main" id="{41BB2263-AE08-5070-C10A-6F79FBFED679}"/>
+              </a:ext>
+            </a:extLst>
+          </p:cNvPr>
+          <p:cNvPicPr>
+            <a:picLocks/>
+          </p:cNvPicPr>
+          <p:nvPr/>
+        </p:nvPicPr>
+        <p:blipFill>
+          <a:blip r:embed="rId5"/>
+          <a:stretch>
+            <a:fillRect/>
+          </a:stretch>
+        </p:blipFill>
+        <p:spPr>
+          <a:xfrm>
+            <a:off x="8280400" y="2406650"/>
+            <a:ext cx="182880" cy="182880"/>
+          </a:xfrm>
+          <a:prstGeom prst="rect">
+            <a:avLst/>
+          </a:prstGeom>
+        </p:spPr>
+      </p:pic>
+      <p:sp>
+        <p:nvSpPr>
+          <p:cNvPr id="120" name="Text"/>
+          <p:cNvSpPr txBox="1"/>
+          <p:nvPr/>
+        </p:nvSpPr>
+        <p:spPr>
+          <a:xfrm>
+            <a:off x="8636000" y="2298700"/>
+            <a:ext cx="2971800" cy="558800"/>
+          </a:xfrm>
+          <a:prstGeom prst="rect">
+            <a:avLst/>
+          </a:prstGeom>
+          <a:noFill/>
+        </p:spPr>
+        <p:txBody>
+          <a:bodyPr wrap="square" lIns="0" tIns="0" rIns="0" bIns="0" rtlCol="0" anchor="ctr"/>
+          <a:lstStyle/>
+          <a:p>
+            <a:pPr marL="0" indent="0" algn="l">
+              <a:spcAft>
+                <a:spcPts val="100"/>
+              </a:spcAft>
+              <a:buNone/>
+            </a:pPr>
+            <a:r>
+              <a:rPr lang="es-VE" sz="1150" b="1">
+                <a:solidFill>
+                  <a:srgbClr val="0E2438"/>
+                </a:solidFill>
+                <a:latin typeface="Cambria" pitchFamily="34" charset="0"/>
+                <a:ea typeface="Cambria" pitchFamily="34" charset="-122"/>
+                <a:cs typeface="Cambria" pitchFamily="34" charset="-120"/>
+              </a:rPr>
+              <a:t>Cada envío queda registrado</a:t>
+            </a:r>
+            <a:endParaRPr lang="es-VE" sz="1150" b="1" dirty="0">
+              <a:solidFill>
+                <a:srgbClr val="0E2438"/>
+              </a:solidFill>
+              <a:latin typeface="Cambria" pitchFamily="34" charset="0"/>
+              <a:ea typeface="Cambria" pitchFamily="34" charset="-122"/>
+              <a:cs typeface="Cambria" pitchFamily="34" charset="-120"/>
+            </a:endParaRPr>
+          </a:p>
+          <a:p>
+            <a:pPr marL="0" indent="0" algn="l">
+              <a:lnSpc>
+                <a:spcPct val="100000"/>
+              </a:lnSpc>
+              <a:buNone/>
+            </a:pPr>
+            <a:r>
+              <a:rPr lang="es-ES" sz="950">
+                <a:solidFill>
+                  <a:srgbClr val="7C8B99"/>
+                </a:solidFill>
+                <a:latin typeface="Calibri" pitchFamily="34" charset="0"/>
+                <a:ea typeface="Calibri" pitchFamily="34" charset="-122"/>
+                <a:cs typeface="Calibri" pitchFamily="34" charset="-120"/>
+              </a:rPr>
+              <a:t>Historial de reportes enviados, con fecha, turno y PDF.</a:t>
+            </a:r>
+            <a:endParaRPr lang="es-VE" sz="950" dirty="0">
+              <a:solidFill>
+                <a:srgbClr val="7C8B99"/>
+              </a:solidFill>
+              <a:latin typeface="Calibri" pitchFamily="34" charset="0"/>
+              <a:ea typeface="Calibri" pitchFamily="34" charset="-122"/>
+              <a:cs typeface="Calibri" pitchFamily="34" charset="-120"/>
+            </a:endParaRPr>
+          </a:p>
+        </p:txBody>
+      </p:sp>
+      <p:sp>
+        <p:nvSpPr>
+          <p:cNvPr id="121" name="Shape"/>
+          <p:cNvSpPr/>
+          <p:nvPr/>
+        </p:nvSpPr>
+        <p:spPr>
+          <a:xfrm>
+            <a:off x="8077200" y="4698999"/>
+            <a:ext cx="3657600" cy="1371600"/>
           </a:xfrm>
           <a:prstGeom prst="roundRect">
             <a:avLst>
               <a:gd name="adj" fmla="val 7000"/>
+            </a:avLst>
+          </a:prstGeom>
+          <a:solidFill>
+            <a:srgbClr val="0E2438"/>
+          </a:solidFill>
+          <a:ln>
+            <a:noFill/>
+          </a:ln>
+        </p:spPr>
+        <p:txBody>
+          <a:bodyPr/>
+          <a:lstStyle/>
+          <a:p>
+            <a:endParaRPr lang="en-US"/>
+          </a:p>
+        </p:txBody>
+      </p:sp>
+      <p:sp>
+        <p:nvSpPr>
+          <p:cNvPr id="4" name="Rectangle: Rounded Corners 3">
+            <a:extLst>
+              <a:ext uri="{FF2B5EF4-FFF2-40B4-BE49-F238E27FC236}">
+                <a16:creationId xmlns:a16="http://schemas.microsoft.com/office/drawing/2014/main" id="{7560B3CF-C445-33C4-ED0D-52BADEF3A747}"/>
+              </a:ext>
+            </a:extLst>
+          </p:cNvPr>
+          <p:cNvSpPr/>
+          <p:nvPr/>
+        </p:nvSpPr>
+        <p:spPr>
+          <a:xfrm>
+            <a:off x="457200" y="1117600"/>
+            <a:ext cx="2590800" cy="4953000"/>
+          </a:xfrm>
+          <a:prstGeom prst="roundRect">
+            <a:avLst>
+              <a:gd name="adj" fmla="val 9000"/>
+            </a:avLst>
+          </a:prstGeom>
+          <a:solidFill>
+            <a:srgbClr val="0E2438"/>
+          </a:solidFill>
+          <a:ln w="12700" cap="flat" cmpd="sng" algn="ctr">
+            <a:noFill/>
+            <a:prstDash val="solid"/>
+            <a:miter lim="800000"/>
+          </a:ln>
+          <a:effectLst/>
+          <a:extLst>
+            <a:ext uri="{91240B29-F687-4F45-9708-019B960494DF}">
+              <a14:hiddenLine xmlns:a14="http://schemas.microsoft.com/office/drawing/2010/main" w="12700" cap="flat" cmpd="sng" algn="ctr">
+                <a:solidFill>
+                  <a:schemeClr val="accent1">
+                    <a:shade val="15000"/>
+                  </a:schemeClr>
+                </a:solidFill>
+                <a:prstDash val="solid"/>
+                <a:miter lim="800000"/>
+              </a14:hiddenLine>
+            </a:ext>
+          </a:extLst>
+        </p:spPr>
+        <p:style>
+          <a:lnRef idx="2">
+            <a:schemeClr val="accent1">
+              <a:shade val="15000"/>
+            </a:schemeClr>
+          </a:lnRef>
+          <a:fillRef idx="1">
+            <a:schemeClr val="accent1"/>
+          </a:fillRef>
+          <a:effectRef idx="0">
+            <a:schemeClr val="accent1"/>
+          </a:effectRef>
+          <a:fontRef idx="minor">
+            <a:schemeClr val="lt1"/>
+          </a:fontRef>
+        </p:style>
+        <p:txBody>
+          <a:bodyPr rtlCol="0" anchor="ctr"/>
+          <a:lstStyle/>
+          <a:p>
+            <a:pPr algn="ctr"/>
+            <a:endParaRPr lang="en-US"/>
+          </a:p>
+        </p:txBody>
+      </p:sp>
+      <p:pic>
+        <p:nvPicPr>
+          <p:cNvPr id="7" name="Picture 6">
+            <a:extLst>
+              <a:ext uri="{FF2B5EF4-FFF2-40B4-BE49-F238E27FC236}">
+                <a16:creationId xmlns:a16="http://schemas.microsoft.com/office/drawing/2014/main" id="{DDB28A2C-04B7-74F4-5076-98D8B24B43D3}"/>
+              </a:ext>
+            </a:extLst>
+          </p:cNvPr>
+          <p:cNvPicPr>
+            <a:picLocks/>
+          </p:cNvPicPr>
+          <p:nvPr/>
+        </p:nvPicPr>
+        <p:blipFill>
+          <a:blip r:embed="rId6"/>
+          <a:srcRect b="46"/>
+          <a:stretch>
+            <a:fillRect/>
+          </a:stretch>
+        </p:blipFill>
+        <p:spPr>
+          <a:xfrm>
+            <a:off x="558800" y="1244600"/>
+            <a:ext cx="2387600" cy="4699000"/>
+          </a:xfrm>
+          <a:prstGeom prst="rect">
+            <a:avLst/>
+          </a:prstGeom>
+        </p:spPr>
+      </p:pic>
+      <p:sp>
+        <p:nvSpPr>
+          <p:cNvPr id="8" name="Text">
+            <a:extLst>
+              <a:ext uri="{FF2B5EF4-FFF2-40B4-BE49-F238E27FC236}">
+                <a16:creationId xmlns:a16="http://schemas.microsoft.com/office/drawing/2014/main" id="{0EDDA15A-F42E-AAC6-AD59-5DBBC25F2ED5}"/>
+              </a:ext>
+            </a:extLst>
+          </p:cNvPr>
+          <p:cNvSpPr txBox="1"/>
+          <p:nvPr/>
+        </p:nvSpPr>
+        <p:spPr>
+          <a:xfrm>
+            <a:off x="457200" y="6172200"/>
+            <a:ext cx="2794000" cy="237744"/>
+          </a:xfrm>
+          <a:prstGeom prst="rect">
+            <a:avLst/>
+          </a:prstGeom>
+          <a:noFill/>
+        </p:spPr>
+        <p:txBody>
+          <a:bodyPr wrap="square" lIns="0" tIns="0" rIns="0" bIns="0" rtlCol="0" anchor="ctr"/>
+          <a:lstStyle/>
+          <a:p>
+            <a:pPr marL="0" indent="0" algn="l">
+              <a:buNone/>
+            </a:pPr>
+            <a:r>
+              <a:rPr lang="es-ES" sz="1050" b="1" spc="100">
+                <a:solidFill>
+                  <a:srgbClr val="D99B0A"/>
+                </a:solidFill>
+                <a:latin typeface="Calibri" pitchFamily="34" charset="0"/>
+                <a:ea typeface="Calibri" pitchFamily="34" charset="-122"/>
+                <a:cs typeface="Calibri" pitchFamily="34" charset="-120"/>
+              </a:rPr>
+              <a:t>EN EL CHAT</a:t>
+            </a:r>
+            <a:r>
+              <a:rPr lang="es-ES" sz="1050" spc="100">
+                <a:solidFill>
+                  <a:srgbClr val="D99B0A"/>
+                </a:solidFill>
+                <a:latin typeface="Calibri" pitchFamily="34" charset="0"/>
+                <a:ea typeface="Calibri" pitchFamily="34" charset="-122"/>
+                <a:cs typeface="Calibri" pitchFamily="34" charset="-120"/>
+              </a:rPr>
+              <a:t> — alerta y reporte reales</a:t>
+            </a:r>
+            <a:endParaRPr lang="es-VE" sz="1050" spc="100" dirty="0">
+              <a:solidFill>
+                <a:srgbClr val="D99B0A"/>
+              </a:solidFill>
+              <a:latin typeface="Calibri" pitchFamily="34" charset="0"/>
+              <a:ea typeface="Calibri" pitchFamily="34" charset="-122"/>
+              <a:cs typeface="Calibri" pitchFamily="34" charset="-120"/>
+            </a:endParaRPr>
+          </a:p>
+        </p:txBody>
+      </p:sp>
+      <p:sp>
+        <p:nvSpPr>
+          <p:cNvPr id="11" name="Shape">
+            <a:extLst>
+              <a:ext uri="{FF2B5EF4-FFF2-40B4-BE49-F238E27FC236}">
+                <a16:creationId xmlns:a16="http://schemas.microsoft.com/office/drawing/2014/main" id="{8CD37CBF-4DAE-304A-15C2-62953FC5F694}"/>
+              </a:ext>
+            </a:extLst>
+          </p:cNvPr>
+          <p:cNvSpPr/>
+          <p:nvPr/>
+        </p:nvSpPr>
+        <p:spPr>
+          <a:xfrm>
+            <a:off x="3251200" y="3683000"/>
+            <a:ext cx="4572000" cy="2133600"/>
+          </a:xfrm>
+          <a:prstGeom prst="roundRect">
+            <a:avLst>
+              <a:gd name="adj" fmla="val 3000"/>
             </a:avLst>
           </a:prstGeom>
           <a:solidFill>
@@ -10953,35 +11534,13 @@
             </a:solidFill>
             <a:prstDash val="solid"/>
           </a:ln>
-        </p:spPr>
-        <p:txBody>
-          <a:bodyPr/>
-          <a:lstStyle/>
-          <a:p>
-            <a:endParaRPr lang="en-US"/>
-          </a:p>
-        </p:txBody>
-      </p:sp>
-      <p:sp>
-        <p:nvSpPr>
-          <p:cNvPr id="111" name="Shape"/>
-          <p:cNvSpPr/>
-          <p:nvPr/>
-        </p:nvSpPr>
-        <p:spPr>
-          <a:xfrm>
-            <a:off x="594360" y="5688985"/>
-            <a:ext cx="384048" cy="384048"/>
-          </a:xfrm>
-          <a:prstGeom prst="ellipse">
-            <a:avLst/>
-          </a:prstGeom>
-          <a:solidFill>
-            <a:srgbClr val="0E2438"/>
-          </a:solidFill>
-          <a:ln>
-            <a:noFill/>
-          </a:ln>
+          <a:effectLst>
+            <a:outerShdw blurRad="127000" dist="38100" dir="5400000" algn="bl" rotWithShape="0">
+              <a:srgbClr val="0E2438">
+                <a:alpha val="10000"/>
+              </a:srgbClr>
+            </a:outerShdw>
+          </a:effectLst>
         </p:spPr>
         <p:txBody>
           <a:bodyPr/>
@@ -10993,10 +11552,10 @@
       </p:sp>
       <p:pic>
         <p:nvPicPr>
-          <p:cNvPr id="7" name="Picture 6">
+          <p:cNvPr id="14" name="Picture 13">
             <a:extLst>
               <a:ext uri="{FF2B5EF4-FFF2-40B4-BE49-F238E27FC236}">
-                <a16:creationId xmlns:a16="http://schemas.microsoft.com/office/drawing/2014/main" id="{82F55E81-F194-1EC4-88DC-4BFCDE921D44}"/>
+                <a16:creationId xmlns:a16="http://schemas.microsoft.com/office/drawing/2014/main" id="{9CDF5F0C-04CB-7717-A601-BCB5EEB59BD1}"/>
               </a:ext>
             </a:extLst>
           </p:cNvPr>
@@ -11006,15 +11565,16 @@
           <p:nvPr/>
         </p:nvPicPr>
         <p:blipFill>
-          <a:blip r:embed="rId4"/>
+          <a:blip r:embed="rId7"/>
+          <a:srcRect b="844"/>
           <a:stretch>
             <a:fillRect/>
           </a:stretch>
         </p:blipFill>
         <p:spPr>
           <a:xfrm>
-            <a:off x="676656" y="5771281"/>
-            <a:ext cx="219456" cy="219456"/>
+            <a:off x="3327400" y="3759200"/>
+            <a:ext cx="4419600" cy="1981200"/>
           </a:xfrm>
           <a:prstGeom prst="rect">
             <a:avLst/>
@@ -11023,14 +11583,187 @@
       </p:pic>
       <p:sp>
         <p:nvSpPr>
-          <p:cNvPr id="113" name="Text"/>
-          <p:cNvSpPr txBox="1"/>
-          <p:nvPr/>
-        </p:nvSpPr>
-        <p:spPr>
-          <a:xfrm>
-            <a:off x="1097280" y="5451241"/>
-            <a:ext cx="1706880" cy="859536"/>
+          <p:cNvPr id="15" name="Text">
+            <a:extLst>
+              <a:ext uri="{FF2B5EF4-FFF2-40B4-BE49-F238E27FC236}">
+                <a16:creationId xmlns:a16="http://schemas.microsoft.com/office/drawing/2014/main" id="{0786754E-1291-3C88-313F-DD03506B4DC2}"/>
+              </a:ext>
+            </a:extLst>
+          </p:cNvPr>
+          <p:cNvSpPr txBox="1"/>
+          <p:nvPr/>
+        </p:nvSpPr>
+        <p:spPr>
+          <a:xfrm>
+            <a:off x="3327400" y="5867400"/>
+            <a:ext cx="4572000" cy="237744"/>
+          </a:xfrm>
+          <a:prstGeom prst="rect">
+            <a:avLst/>
+          </a:prstGeom>
+          <a:noFill/>
+        </p:spPr>
+        <p:txBody>
+          <a:bodyPr wrap="square" lIns="0" tIns="0" rIns="0" bIns="0" rtlCol="0" anchor="ctr"/>
+          <a:lstStyle/>
+          <a:p>
+            <a:pPr marL="0" indent="0" algn="l">
+              <a:buNone/>
+            </a:pPr>
+            <a:r>
+              <a:rPr lang="es-ES" sz="1050" b="1" spc="100">
+                <a:solidFill>
+                  <a:srgbClr val="D99B0A"/>
+                </a:solidFill>
+                <a:latin typeface="Calibri" pitchFamily="34" charset="0"/>
+                <a:ea typeface="Calibri" pitchFamily="34" charset="-122"/>
+                <a:cs typeface="Calibri" pitchFamily="34" charset="-120"/>
+              </a:rPr>
+              <a:t>SUSCRIPTORES DE TELEGRAM</a:t>
+            </a:r>
+            <a:r>
+              <a:rPr lang="es-ES" sz="1050" spc="100">
+                <a:solidFill>
+                  <a:srgbClr val="D99B0A"/>
+                </a:solidFill>
+                <a:latin typeface="Calibri" pitchFamily="34" charset="0"/>
+                <a:ea typeface="Calibri" pitchFamily="34" charset="-122"/>
+                <a:cs typeface="Calibri" pitchFamily="34" charset="-120"/>
+              </a:rPr>
+              <a:t> — acceso con aprobación</a:t>
+            </a:r>
+            <a:endParaRPr lang="es-VE" sz="1050" spc="100" dirty="0">
+              <a:solidFill>
+                <a:srgbClr val="D99B0A"/>
+              </a:solidFill>
+              <a:latin typeface="Calibri" pitchFamily="34" charset="0"/>
+              <a:ea typeface="Calibri" pitchFamily="34" charset="-122"/>
+              <a:cs typeface="Calibri" pitchFamily="34" charset="-120"/>
+            </a:endParaRPr>
+          </a:p>
+        </p:txBody>
+      </p:sp>
+      <p:sp>
+        <p:nvSpPr>
+          <p:cNvPr id="16" name="Shape">
+            <a:extLst>
+              <a:ext uri="{FF2B5EF4-FFF2-40B4-BE49-F238E27FC236}">
+                <a16:creationId xmlns:a16="http://schemas.microsoft.com/office/drawing/2014/main" id="{0DEE6B3A-63FA-5822-C8EF-E096F505D1A4}"/>
+              </a:ext>
+            </a:extLst>
+          </p:cNvPr>
+          <p:cNvSpPr/>
+          <p:nvPr/>
+        </p:nvSpPr>
+        <p:spPr>
+          <a:xfrm>
+            <a:off x="8077200" y="3022600"/>
+            <a:ext cx="3657600" cy="736600"/>
+          </a:xfrm>
+          <a:prstGeom prst="roundRect">
+            <a:avLst>
+              <a:gd name="adj" fmla="val 8000"/>
+            </a:avLst>
+          </a:prstGeom>
+          <a:solidFill>
+            <a:srgbClr val="F7FAFC"/>
+          </a:solidFill>
+          <a:ln w="12700">
+            <a:solidFill>
+              <a:srgbClr val="DDE3EA"/>
+            </a:solidFill>
+            <a:prstDash val="solid"/>
+          </a:ln>
+        </p:spPr>
+        <p:txBody>
+          <a:bodyPr/>
+          <a:lstStyle/>
+          <a:p>
+            <a:endParaRPr lang="en-US"/>
+          </a:p>
+        </p:txBody>
+      </p:sp>
+      <p:sp>
+        <p:nvSpPr>
+          <p:cNvPr id="17" name="Shape">
+            <a:extLst>
+              <a:ext uri="{FF2B5EF4-FFF2-40B4-BE49-F238E27FC236}">
+                <a16:creationId xmlns:a16="http://schemas.microsoft.com/office/drawing/2014/main" id="{9CB7041F-FB9B-5088-62E4-CF622C825F68}"/>
+              </a:ext>
+            </a:extLst>
+          </p:cNvPr>
+          <p:cNvSpPr/>
+          <p:nvPr/>
+        </p:nvSpPr>
+        <p:spPr>
+          <a:xfrm>
+            <a:off x="8216900" y="3162300"/>
+            <a:ext cx="292608" cy="292608"/>
+          </a:xfrm>
+          <a:prstGeom prst="ellipse">
+            <a:avLst/>
+          </a:prstGeom>
+          <a:solidFill>
+            <a:srgbClr val="1E4D6B"/>
+          </a:solidFill>
+          <a:ln>
+            <a:noFill/>
+          </a:ln>
+        </p:spPr>
+        <p:txBody>
+          <a:bodyPr/>
+          <a:lstStyle/>
+          <a:p>
+            <a:endParaRPr lang="en-US"/>
+          </a:p>
+        </p:txBody>
+      </p:sp>
+      <p:pic>
+        <p:nvPicPr>
+          <p:cNvPr id="29" name="Picture 28">
+            <a:extLst>
+              <a:ext uri="{FF2B5EF4-FFF2-40B4-BE49-F238E27FC236}">
+                <a16:creationId xmlns:a16="http://schemas.microsoft.com/office/drawing/2014/main" id="{70F7E51C-2633-0AB9-2496-30BC5FA2E8B3}"/>
+              </a:ext>
+            </a:extLst>
+          </p:cNvPr>
+          <p:cNvPicPr>
+            <a:picLocks/>
+          </p:cNvPicPr>
+          <p:nvPr/>
+        </p:nvPicPr>
+        <p:blipFill>
+          <a:blip r:embed="rId8"/>
+          <a:stretch>
+            <a:fillRect/>
+          </a:stretch>
+        </p:blipFill>
+        <p:spPr>
+          <a:xfrm>
+            <a:off x="8280400" y="3219450"/>
+            <a:ext cx="182880" cy="182880"/>
+          </a:xfrm>
+          <a:prstGeom prst="rect">
+            <a:avLst/>
+          </a:prstGeom>
+        </p:spPr>
+      </p:pic>
+      <p:sp>
+        <p:nvSpPr>
+          <p:cNvPr id="19" name="Text">
+            <a:extLst>
+              <a:ext uri="{FF2B5EF4-FFF2-40B4-BE49-F238E27FC236}">
+                <a16:creationId xmlns:a16="http://schemas.microsoft.com/office/drawing/2014/main" id="{D064A10A-2B04-7676-F80B-7AF1D61E7658}"/>
+              </a:ext>
+            </a:extLst>
+          </p:cNvPr>
+          <p:cNvSpPr txBox="1"/>
+          <p:nvPr/>
+        </p:nvSpPr>
+        <p:spPr>
+          <a:xfrm>
+            <a:off x="8636000" y="3111500"/>
+            <a:ext cx="2971800" cy="558800"/>
           </a:xfrm>
           <a:prstGeom prst="rect">
             <a:avLst/>
@@ -11048,7 +11781,7 @@
               <a:buNone/>
             </a:pPr>
             <a:r>
-              <a:rPr lang="es-VE" sz="1200" b="1">
+              <a:rPr lang="es-VE" sz="1150" b="1">
                 <a:solidFill>
                   <a:srgbClr val="0E2438"/>
                 </a:solidFill>
@@ -11056,9 +11789,9 @@
                 <a:ea typeface="Cambria" pitchFamily="34" charset="-122"/>
                 <a:cs typeface="Cambria" pitchFamily="34" charset="-120"/>
               </a:rPr>
-              <a:t>Con aprobación</a:t>
-            </a:r>
-            <a:endParaRPr lang="es-VE" sz="1200" b="1" dirty="0">
+              <a:t>Acceso que se retira</a:t>
+            </a:r>
+            <a:endParaRPr lang="es-VE" sz="1150" b="1" dirty="0">
               <a:solidFill>
                 <a:srgbClr val="0E2438"/>
               </a:solidFill>
@@ -11075,7 +11808,7 @@
               <a:buNone/>
             </a:pPr>
             <a:r>
-              <a:rPr lang="es-ES" sz="1000">
+              <a:rPr lang="es-ES" sz="950">
                 <a:solidFill>
                   <a:srgbClr val="7C8B99"/>
                 </a:solidFill>
@@ -11083,9 +11816,9 @@
                 <a:ea typeface="Calibri" pitchFamily="34" charset="-122"/>
                 <a:cs typeface="Calibri" pitchFamily="34" charset="-120"/>
               </a:rPr>
-              <a:t>Quien escribe al bot queda pendiente hasta que se aprueba.</a:t>
-            </a:r>
-            <a:endParaRPr lang="es-VE" sz="1000" dirty="0">
+              <a:t>"Quitar acceso" lo corta al instante y no se reactiva solo.</a:t>
+            </a:r>
+            <a:endParaRPr lang="es-VE" sz="950" dirty="0">
               <a:solidFill>
                 <a:srgbClr val="7C8B99"/>
               </a:solidFill>
@@ -11098,22 +11831,28 @@
       </p:sp>
       <p:sp>
         <p:nvSpPr>
-          <p:cNvPr id="114" name="Shape"/>
+          <p:cNvPr id="20" name="Shape">
+            <a:extLst>
+              <a:ext uri="{FF2B5EF4-FFF2-40B4-BE49-F238E27FC236}">
+                <a16:creationId xmlns:a16="http://schemas.microsoft.com/office/drawing/2014/main" id="{5FB2960D-12FE-4090-76B5-EA651029DA44}"/>
+              </a:ext>
+            </a:extLst>
+          </p:cNvPr>
           <p:cNvSpPr/>
           <p:nvPr/>
         </p:nvSpPr>
         <p:spPr>
           <a:xfrm>
-            <a:off x="3032760" y="5378089"/>
-            <a:ext cx="2438400" cy="1005840"/>
+            <a:off x="8077200" y="3835400"/>
+            <a:ext cx="3657600" cy="736600"/>
           </a:xfrm>
           <a:prstGeom prst="roundRect">
             <a:avLst>
-              <a:gd name="adj" fmla="val 7000"/>
+              <a:gd name="adj" fmla="val 8000"/>
             </a:avLst>
           </a:prstGeom>
           <a:solidFill>
-            <a:srgbClr val="FFFFFF"/>
+            <a:srgbClr val="F7FAFC"/>
           </a:solidFill>
           <a:ln w="12700">
             <a:solidFill>
@@ -11132,20 +11871,26 @@
       </p:sp>
       <p:sp>
         <p:nvSpPr>
-          <p:cNvPr id="115" name="Shape"/>
+          <p:cNvPr id="21" name="Shape">
+            <a:extLst>
+              <a:ext uri="{FF2B5EF4-FFF2-40B4-BE49-F238E27FC236}">
+                <a16:creationId xmlns:a16="http://schemas.microsoft.com/office/drawing/2014/main" id="{C903EACB-2189-FFEF-4717-D5753BD3FA7A}"/>
+              </a:ext>
+            </a:extLst>
+          </p:cNvPr>
           <p:cNvSpPr/>
           <p:nvPr/>
         </p:nvSpPr>
         <p:spPr>
           <a:xfrm>
-            <a:off x="3169920" y="5688985"/>
-            <a:ext cx="384048" cy="384048"/>
+            <a:off x="8216900" y="3975100"/>
+            <a:ext cx="292608" cy="292608"/>
           </a:xfrm>
           <a:prstGeom prst="ellipse">
             <a:avLst/>
           </a:prstGeom>
           <a:solidFill>
-            <a:srgbClr val="0E2438"/>
+            <a:srgbClr val="1E4D6B"/>
           </a:solidFill>
           <a:ln>
             <a:noFill/>
@@ -11161,10 +11906,10 @@
       </p:sp>
       <p:pic>
         <p:nvPicPr>
-          <p:cNvPr id="9" name="Picture 8">
+          <p:cNvPr id="31" name="Picture 30">
             <a:extLst>
               <a:ext uri="{FF2B5EF4-FFF2-40B4-BE49-F238E27FC236}">
-                <a16:creationId xmlns:a16="http://schemas.microsoft.com/office/drawing/2014/main" id="{19E04073-39E7-93AC-7325-439400116A6D}"/>
+                <a16:creationId xmlns:a16="http://schemas.microsoft.com/office/drawing/2014/main" id="{D30B0B64-09C7-DCB3-481A-B3077B587D97}"/>
               </a:ext>
             </a:extLst>
           </p:cNvPr>
@@ -11174,15 +11919,15 @@
           <p:nvPr/>
         </p:nvPicPr>
         <p:blipFill>
-          <a:blip r:embed="rId5"/>
+          <a:blip r:embed="rId9"/>
           <a:stretch>
             <a:fillRect/>
           </a:stretch>
         </p:blipFill>
         <p:spPr>
           <a:xfrm>
-            <a:off x="3252216" y="5771281"/>
-            <a:ext cx="219456" cy="219456"/>
+            <a:off x="8280400" y="4032250"/>
+            <a:ext cx="182880" cy="182880"/>
           </a:xfrm>
           <a:prstGeom prst="rect">
             <a:avLst/>
@@ -11191,14 +11936,20 @@
       </p:pic>
       <p:sp>
         <p:nvSpPr>
-          <p:cNvPr id="117" name="Text"/>
-          <p:cNvSpPr txBox="1"/>
-          <p:nvPr/>
-        </p:nvSpPr>
-        <p:spPr>
-          <a:xfrm>
-            <a:off x="3672840" y="5451241"/>
-            <a:ext cx="1706880" cy="859536"/>
+          <p:cNvPr id="23" name="Text">
+            <a:extLst>
+              <a:ext uri="{FF2B5EF4-FFF2-40B4-BE49-F238E27FC236}">
+                <a16:creationId xmlns:a16="http://schemas.microsoft.com/office/drawing/2014/main" id="{DE096D1F-B58D-F6A2-E416-EA92C07D4F84}"/>
+              </a:ext>
+            </a:extLst>
+          </p:cNvPr>
+          <p:cNvSpPr txBox="1"/>
+          <p:nvPr/>
+        </p:nvSpPr>
+        <p:spPr>
+          <a:xfrm>
+            <a:off x="8636000" y="3924300"/>
+            <a:ext cx="2971800" cy="558800"/>
           </a:xfrm>
           <a:prstGeom prst="rect">
             <a:avLst/>
@@ -11216,7 +11967,7 @@
               <a:buNone/>
             </a:pPr>
             <a:r>
-              <a:rPr lang="es-VE" sz="1200" b="1">
+              <a:rPr lang="es-VE" sz="1150" b="1">
                 <a:solidFill>
                   <a:srgbClr val="0E2438"/>
                 </a:solidFill>
@@ -11224,9 +11975,9 @@
                 <a:ea typeface="Cambria" pitchFamily="34" charset="-122"/>
                 <a:cs typeface="Cambria" pitchFamily="34" charset="-120"/>
               </a:rPr>
-              <a:t>Quitar acceso</a:t>
-            </a:r>
-            <a:endParaRPr lang="es-VE" sz="1200" b="1" dirty="0">
+              <a:t>Aviso de cada solicitud</a:t>
+            </a:r>
+            <a:endParaRPr lang="es-VE" sz="1150" b="1" dirty="0">
               <a:solidFill>
                 <a:srgbClr val="0E2438"/>
               </a:solidFill>
@@ -11243,7 +11994,7 @@
               <a:buNone/>
             </a:pPr>
             <a:r>
-              <a:rPr lang="es-ES" sz="1000">
+              <a:rPr lang="es-ES" sz="950">
                 <a:solidFill>
                   <a:srgbClr val="7C8B99"/>
                 </a:solidFill>
@@ -11251,9 +12002,9 @@
                 <a:ea typeface="Calibri" pitchFamily="34" charset="-122"/>
                 <a:cs typeface="Calibri" pitchFamily="34" charset="-120"/>
               </a:rPr>
-              <a:t>Deja de recibir al instante y no se reactiva solo.</a:t>
-            </a:r>
-            <a:endParaRPr lang="es-VE" sz="1000" dirty="0">
+              <a:t>Si alguien nuevo pide acceso, llega un aviso al chat.</a:t>
+            </a:r>
+            <a:endParaRPr lang="es-VE" sz="950" dirty="0">
               <a:solidFill>
                 <a:srgbClr val="7C8B99"/>
               </a:solidFill>
@@ -11266,555 +12017,20 @@
       </p:sp>
       <p:sp>
         <p:nvSpPr>
-          <p:cNvPr id="118" name="Shape"/>
-          <p:cNvSpPr/>
-          <p:nvPr/>
-        </p:nvSpPr>
-        <p:spPr>
-          <a:xfrm>
-            <a:off x="5608320" y="5378089"/>
-            <a:ext cx="2438400" cy="1005840"/>
-          </a:xfrm>
-          <a:prstGeom prst="roundRect">
-            <a:avLst>
-              <a:gd name="adj" fmla="val 7000"/>
-            </a:avLst>
-          </a:prstGeom>
-          <a:solidFill>
-            <a:srgbClr val="FFFFFF"/>
-          </a:solidFill>
-          <a:ln w="12700">
-            <a:solidFill>
-              <a:srgbClr val="DDE3EA"/>
-            </a:solidFill>
-            <a:prstDash val="solid"/>
-          </a:ln>
-        </p:spPr>
-        <p:txBody>
-          <a:bodyPr/>
-          <a:lstStyle/>
-          <a:p>
-            <a:endParaRPr lang="en-US"/>
-          </a:p>
-        </p:txBody>
-      </p:sp>
-      <p:sp>
-        <p:nvSpPr>
-          <p:cNvPr id="119" name="Shape"/>
-          <p:cNvSpPr/>
-          <p:nvPr/>
-        </p:nvSpPr>
-        <p:spPr>
-          <a:xfrm>
-            <a:off x="5745480" y="5688985"/>
-            <a:ext cx="384048" cy="384048"/>
-          </a:xfrm>
-          <a:prstGeom prst="ellipse">
-            <a:avLst/>
-          </a:prstGeom>
-          <a:solidFill>
-            <a:srgbClr val="0E2438"/>
-          </a:solidFill>
-          <a:ln>
-            <a:noFill/>
-          </a:ln>
-        </p:spPr>
-        <p:txBody>
-          <a:bodyPr/>
-          <a:lstStyle/>
-          <a:p>
-            <a:endParaRPr lang="en-US"/>
-          </a:p>
-        </p:txBody>
-      </p:sp>
-      <p:pic>
-        <p:nvPicPr>
-          <p:cNvPr id="11" name="Picture 10">
+          <p:cNvPr id="32" name="TextBox 31">
             <a:extLst>
               <a:ext uri="{FF2B5EF4-FFF2-40B4-BE49-F238E27FC236}">
-                <a16:creationId xmlns:a16="http://schemas.microsoft.com/office/drawing/2014/main" id="{E247AB26-6E2E-2A7F-1721-85671EE94FB2}"/>
+                <a16:creationId xmlns:a16="http://schemas.microsoft.com/office/drawing/2014/main" id="{A707F4AD-B049-2748-DD04-CC6F90A5004A}"/>
               </a:ext>
             </a:extLst>
           </p:cNvPr>
-          <p:cNvPicPr>
-            <a:picLocks/>
-          </p:cNvPicPr>
-          <p:nvPr/>
-        </p:nvPicPr>
-        <p:blipFill>
-          <a:blip r:embed="rId6"/>
-          <a:stretch>
-            <a:fillRect/>
-          </a:stretch>
-        </p:blipFill>
-        <p:spPr>
-          <a:xfrm>
-            <a:off x="5827776" y="5771281"/>
-            <a:ext cx="219456" cy="219456"/>
-          </a:xfrm>
-          <a:prstGeom prst="rect">
-            <a:avLst/>
-          </a:prstGeom>
-        </p:spPr>
-      </p:pic>
-      <p:sp>
-        <p:nvSpPr>
-          <p:cNvPr id="121" name="Text"/>
-          <p:cNvSpPr txBox="1"/>
-          <p:nvPr/>
-        </p:nvSpPr>
-        <p:spPr>
-          <a:xfrm>
-            <a:off x="6248400" y="5451241"/>
-            <a:ext cx="1706880" cy="859536"/>
-          </a:xfrm>
-          <a:prstGeom prst="rect">
-            <a:avLst/>
-          </a:prstGeom>
-          <a:noFill/>
-        </p:spPr>
-        <p:txBody>
-          <a:bodyPr wrap="square" lIns="0" tIns="0" rIns="0" bIns="0" rtlCol="0" anchor="ctr"/>
-          <a:lstStyle/>
-          <a:p>
-            <a:pPr marL="0" indent="0" algn="l">
-              <a:spcAft>
-                <a:spcPts val="100"/>
-              </a:spcAft>
-              <a:buNone/>
-            </a:pPr>
-            <a:r>
-              <a:rPr lang="es-VE" sz="1200" b="1">
-                <a:solidFill>
-                  <a:srgbClr val="0E2438"/>
-                </a:solidFill>
-                <a:latin typeface="Cambria" pitchFamily="34" charset="0"/>
-                <a:ea typeface="Cambria" pitchFamily="34" charset="-122"/>
-                <a:cs typeface="Cambria" pitchFamily="34" charset="-120"/>
-              </a:rPr>
-              <a:t>Aviso de solicitud</a:t>
-            </a:r>
-            <a:endParaRPr lang="es-VE" sz="1200" b="1" dirty="0">
-              <a:solidFill>
-                <a:srgbClr val="0E2438"/>
-              </a:solidFill>
-              <a:latin typeface="Cambria" pitchFamily="34" charset="0"/>
-              <a:ea typeface="Cambria" pitchFamily="34" charset="-122"/>
-              <a:cs typeface="Cambria" pitchFamily="34" charset="-120"/>
-            </a:endParaRPr>
-          </a:p>
-          <a:p>
-            <a:pPr marL="0" indent="0" algn="l">
-              <a:lnSpc>
-                <a:spcPct val="100000"/>
-              </a:lnSpc>
-              <a:buNone/>
-            </a:pPr>
-            <a:r>
-              <a:rPr lang="es-ES" sz="1000">
-                <a:solidFill>
-                  <a:srgbClr val="7C8B99"/>
-                </a:solidFill>
-                <a:latin typeface="Calibri" pitchFamily="34" charset="0"/>
-                <a:ea typeface="Calibri" pitchFamily="34" charset="-122"/>
-                <a:cs typeface="Calibri" pitchFamily="34" charset="-120"/>
-              </a:rPr>
-              <a:t>Cada pedido nuevo se avisa por el mismo bot.</a:t>
-            </a:r>
-            <a:endParaRPr lang="es-VE" sz="1000" dirty="0">
-              <a:solidFill>
-                <a:srgbClr val="7C8B99"/>
-              </a:solidFill>
-              <a:latin typeface="Calibri" pitchFamily="34" charset="0"/>
-              <a:ea typeface="Calibri" pitchFamily="34" charset="-122"/>
-              <a:cs typeface="Calibri" pitchFamily="34" charset="-120"/>
-            </a:endParaRPr>
-          </a:p>
-        </p:txBody>
-      </p:sp>
-      <p:sp>
-        <p:nvSpPr>
-          <p:cNvPr id="122" name="Text"/>
-          <p:cNvSpPr txBox="1"/>
-          <p:nvPr/>
-        </p:nvSpPr>
-        <p:spPr>
-          <a:xfrm>
-            <a:off x="8366760" y="1143000"/>
-            <a:ext cx="3367735" cy="256032"/>
-          </a:xfrm>
-          <a:prstGeom prst="rect">
-            <a:avLst/>
-          </a:prstGeom>
-          <a:noFill/>
-        </p:spPr>
-        <p:txBody>
-          <a:bodyPr wrap="square" lIns="0" tIns="0" rIns="0" bIns="0" rtlCol="0" anchor="ctr"/>
-          <a:lstStyle/>
-          <a:p>
-            <a:pPr marL="0" indent="0" algn="l">
-              <a:buNone/>
-            </a:pPr>
-            <a:r>
-              <a:rPr lang="es-VE" sz="1050" b="1" spc="150">
-                <a:solidFill>
-                  <a:srgbClr val="D99B0A"/>
-                </a:solidFill>
-                <a:latin typeface="Calibri" pitchFamily="34" charset="0"/>
-                <a:ea typeface="Calibri" pitchFamily="34" charset="-122"/>
-                <a:cs typeface="Calibri" pitchFamily="34" charset="-120"/>
-              </a:rPr>
-              <a:t>QUÉ LLEGA AL CHAT</a:t>
-            </a:r>
-            <a:endParaRPr lang="es-VE" sz="1050" b="1" spc="150" dirty="0">
-              <a:solidFill>
-                <a:srgbClr val="D99B0A"/>
-              </a:solidFill>
-              <a:latin typeface="Calibri" pitchFamily="34" charset="0"/>
-              <a:ea typeface="Calibri" pitchFamily="34" charset="-122"/>
-              <a:cs typeface="Calibri" pitchFamily="34" charset="-120"/>
-            </a:endParaRPr>
-          </a:p>
-        </p:txBody>
-      </p:sp>
-      <p:sp>
-        <p:nvSpPr>
-          <p:cNvPr id="123" name="Text"/>
-          <p:cNvSpPr txBox="1"/>
-          <p:nvPr/>
-        </p:nvSpPr>
-        <p:spPr>
-          <a:xfrm>
-            <a:off x="8366760" y="1472184"/>
-            <a:ext cx="3367735" cy="2103120"/>
-          </a:xfrm>
-          <a:prstGeom prst="rect">
-            <a:avLst/>
-          </a:prstGeom>
-          <a:noFill/>
-        </p:spPr>
-        <p:txBody>
-          <a:bodyPr wrap="square" lIns="0" tIns="0" rIns="0" bIns="0" rtlCol="0" anchor="t"/>
-          <a:lstStyle/>
-          <a:p>
-            <a:pPr marL="177800" indent="-177800" algn="l">
-              <a:lnSpc>
-                <a:spcPct val="110000"/>
-              </a:lnSpc>
-              <a:spcAft>
-                <a:spcPts val="700"/>
-              </a:spcAft>
-              <a:buClr>
-                <a:srgbClr val="0E2438"/>
-              </a:buClr>
-              <a:buSzPct val="100000"/>
-              <a:buChar char="•"/>
-            </a:pPr>
-            <a:r>
-              <a:rPr lang="es-ES" sz="1150">
-                <a:solidFill>
-                  <a:srgbClr val="15324D"/>
-                </a:solidFill>
-                <a:latin typeface="Calibri" pitchFamily="34" charset="0"/>
-                <a:ea typeface="Calibri" pitchFamily="34" charset="-122"/>
-                <a:cs typeface="Calibri" pitchFamily="34" charset="-120"/>
-              </a:rPr>
-              <a:t>Las alertas de geocerca y de fuera de horario, con mapa y recorrido del día.</a:t>
-            </a:r>
-            <a:endParaRPr lang="es-VE" sz="1150" dirty="0">
-              <a:solidFill>
-                <a:srgbClr val="15324D"/>
-              </a:solidFill>
-              <a:latin typeface="Calibri" pitchFamily="34" charset="0"/>
-              <a:ea typeface="Calibri" pitchFamily="34" charset="-122"/>
-              <a:cs typeface="Calibri" pitchFamily="34" charset="-120"/>
-            </a:endParaRPr>
-          </a:p>
-          <a:p>
-            <a:pPr marL="177800" indent="-177800" algn="l">
-              <a:lnSpc>
-                <a:spcPct val="110000"/>
-              </a:lnSpc>
-              <a:spcAft>
-                <a:spcPts val="700"/>
-              </a:spcAft>
-              <a:buClr>
-                <a:srgbClr val="0E2438"/>
-              </a:buClr>
-              <a:buSzPct val="100000"/>
-              <a:buChar char="•"/>
-            </a:pPr>
-            <a:r>
-              <a:rPr lang="es-ES" sz="1150">
-                <a:solidFill>
-                  <a:srgbClr val="15324D"/>
-                </a:solidFill>
-                <a:latin typeface="Calibri" pitchFamily="34" charset="0"/>
-                <a:ea typeface="Calibri" pitchFamily="34" charset="-122"/>
-                <a:cs typeface="Calibri" pitchFamily="34" charset="-120"/>
-              </a:rPr>
-              <a:t>Los reportes de turno, con el PDF adjunto.</a:t>
-            </a:r>
-            <a:endParaRPr lang="es-VE" sz="1150" dirty="0">
-              <a:solidFill>
-                <a:srgbClr val="15324D"/>
-              </a:solidFill>
-              <a:latin typeface="Calibri" pitchFamily="34" charset="0"/>
-              <a:ea typeface="Calibri" pitchFamily="34" charset="-122"/>
-              <a:cs typeface="Calibri" pitchFamily="34" charset="-120"/>
-            </a:endParaRPr>
-          </a:p>
-          <a:p>
-            <a:pPr marL="177800" indent="-177800" algn="l">
-              <a:lnSpc>
-                <a:spcPct val="110000"/>
-              </a:lnSpc>
-              <a:spcAft>
-                <a:spcPts val="700"/>
-              </a:spcAft>
-              <a:buClr>
-                <a:srgbClr val="0E2438"/>
-              </a:buClr>
-              <a:buSzPct val="100000"/>
-              <a:buChar char="•"/>
-            </a:pPr>
-            <a:r>
-              <a:rPr lang="es-ES" sz="1150">
-                <a:solidFill>
-                  <a:srgbClr val="15324D"/>
-                </a:solidFill>
-                <a:latin typeface="Calibri" pitchFamily="34" charset="0"/>
-                <a:ea typeface="Calibri" pitchFamily="34" charset="-122"/>
-                <a:cs typeface="Calibri" pitchFamily="34" charset="-120"/>
-              </a:rPr>
-              <a:t>El aviso cuando alguien nuevo pide acceso.</a:t>
-            </a:r>
-            <a:endParaRPr lang="es-VE" sz="1150" dirty="0">
-              <a:solidFill>
-                <a:srgbClr val="15324D"/>
-              </a:solidFill>
-              <a:latin typeface="Calibri" pitchFamily="34" charset="0"/>
-              <a:ea typeface="Calibri" pitchFamily="34" charset="-122"/>
-              <a:cs typeface="Calibri" pitchFamily="34" charset="-120"/>
-            </a:endParaRPr>
-          </a:p>
-        </p:txBody>
-      </p:sp>
-      <p:sp>
-        <p:nvSpPr>
-          <p:cNvPr id="124" name="Text"/>
-          <p:cNvSpPr txBox="1"/>
-          <p:nvPr/>
-        </p:nvSpPr>
-        <p:spPr>
-          <a:xfrm>
-            <a:off x="8366760" y="3017520"/>
-            <a:ext cx="3367735" cy="256032"/>
-          </a:xfrm>
-          <a:prstGeom prst="rect">
-            <a:avLst/>
-          </a:prstGeom>
-          <a:noFill/>
-        </p:spPr>
-        <p:txBody>
-          <a:bodyPr wrap="square" lIns="0" tIns="0" rIns="0" bIns="0" rtlCol="0" anchor="ctr"/>
-          <a:lstStyle/>
-          <a:p>
-            <a:pPr marL="0" indent="0" algn="l">
-              <a:buNone/>
-            </a:pPr>
-            <a:r>
-              <a:rPr lang="es-VE" sz="1050" b="1" spc="150">
-                <a:solidFill>
-                  <a:srgbClr val="D99B0A"/>
-                </a:solidFill>
-                <a:latin typeface="Calibri" pitchFamily="34" charset="0"/>
-                <a:ea typeface="Calibri" pitchFamily="34" charset="-122"/>
-                <a:cs typeface="Calibri" pitchFamily="34" charset="-120"/>
-              </a:rPr>
-              <a:t>CÓMO SE DA ACCESO</a:t>
-            </a:r>
-            <a:endParaRPr lang="es-VE" sz="1050" b="1" spc="150" dirty="0">
-              <a:solidFill>
-                <a:srgbClr val="D99B0A"/>
-              </a:solidFill>
-              <a:latin typeface="Calibri" pitchFamily="34" charset="0"/>
-              <a:ea typeface="Calibri" pitchFamily="34" charset="-122"/>
-              <a:cs typeface="Calibri" pitchFamily="34" charset="-120"/>
-            </a:endParaRPr>
-          </a:p>
-        </p:txBody>
-      </p:sp>
-      <p:sp>
-        <p:nvSpPr>
-          <p:cNvPr id="125" name="Text"/>
-          <p:cNvSpPr txBox="1"/>
-          <p:nvPr/>
-        </p:nvSpPr>
-        <p:spPr>
-          <a:xfrm>
-            <a:off x="8366760" y="3346704"/>
-            <a:ext cx="3367735" cy="2103120"/>
-          </a:xfrm>
-          <a:prstGeom prst="rect">
-            <a:avLst/>
-          </a:prstGeom>
-          <a:noFill/>
-        </p:spPr>
-        <p:txBody>
-          <a:bodyPr wrap="square" lIns="0" tIns="0" rIns="0" bIns="0" rtlCol="0" anchor="t"/>
-          <a:lstStyle/>
-          <a:p>
-            <a:pPr marL="177800" indent="-177800" algn="l">
-              <a:lnSpc>
-                <a:spcPct val="110000"/>
-              </a:lnSpc>
-              <a:spcAft>
-                <a:spcPts val="700"/>
-              </a:spcAft>
-              <a:buClr>
-                <a:srgbClr val="0E2438"/>
-              </a:buClr>
-              <a:buSzPct val="100000"/>
-              <a:buChar char="•"/>
-            </a:pPr>
-            <a:r>
-              <a:rPr lang="es-ES" sz="1150">
-                <a:solidFill>
-                  <a:srgbClr val="15324D"/>
-                </a:solidFill>
-                <a:latin typeface="Calibri" pitchFamily="34" charset="0"/>
-                <a:ea typeface="Calibri" pitchFamily="34" charset="-122"/>
-                <a:cs typeface="Calibri" pitchFamily="34" charset="-120"/>
-              </a:rPr>
-              <a:t>La persona busca el bot y le escribe un mensaje.</a:t>
-            </a:r>
-            <a:endParaRPr lang="es-VE" sz="1150" dirty="0">
-              <a:solidFill>
-                <a:srgbClr val="15324D"/>
-              </a:solidFill>
-              <a:latin typeface="Calibri" pitchFamily="34" charset="0"/>
-              <a:ea typeface="Calibri" pitchFamily="34" charset="-122"/>
-              <a:cs typeface="Calibri" pitchFamily="34" charset="-120"/>
-            </a:endParaRPr>
-          </a:p>
-          <a:p>
-            <a:pPr marL="177800" indent="-177800" algn="l">
-              <a:lnSpc>
-                <a:spcPct val="110000"/>
-              </a:lnSpc>
-              <a:spcAft>
-                <a:spcPts val="700"/>
-              </a:spcAft>
-              <a:buClr>
-                <a:srgbClr val="0E2438"/>
-              </a:buClr>
-              <a:buSzPct val="100000"/>
-              <a:buChar char="•"/>
-            </a:pPr>
-            <a:r>
-              <a:rPr lang="es-ES" sz="1150">
-                <a:solidFill>
-                  <a:srgbClr val="15324D"/>
-                </a:solidFill>
-                <a:latin typeface="Calibri" pitchFamily="34" charset="0"/>
-                <a:ea typeface="Calibri" pitchFamily="34" charset="-122"/>
-                <a:cs typeface="Calibri" pitchFamily="34" charset="-120"/>
-              </a:rPr>
-              <a:t>Aparece como pendiente y se aprueba aquí.</a:t>
-            </a:r>
-            <a:endParaRPr lang="es-VE" sz="1150" dirty="0">
-              <a:solidFill>
-                <a:srgbClr val="15324D"/>
-              </a:solidFill>
-              <a:latin typeface="Calibri" pitchFamily="34" charset="0"/>
-              <a:ea typeface="Calibri" pitchFamily="34" charset="-122"/>
-              <a:cs typeface="Calibri" pitchFamily="34" charset="-120"/>
-            </a:endParaRPr>
-          </a:p>
-          <a:p>
-            <a:pPr marL="177800" indent="-177800" algn="l">
-              <a:lnSpc>
-                <a:spcPct val="110000"/>
-              </a:lnSpc>
-              <a:spcAft>
-                <a:spcPts val="700"/>
-              </a:spcAft>
-              <a:buClr>
-                <a:srgbClr val="0E2438"/>
-              </a:buClr>
-              <a:buSzPct val="100000"/>
-              <a:buChar char="•"/>
-            </a:pPr>
-            <a:r>
-              <a:rPr lang="es-ES" sz="1150">
-                <a:solidFill>
-                  <a:srgbClr val="15324D"/>
-                </a:solidFill>
-                <a:latin typeface="Calibri" pitchFamily="34" charset="0"/>
-                <a:ea typeface="Calibri" pitchFamily="34" charset="-122"/>
-                <a:cs typeface="Calibri" pitchFamily="34" charset="-120"/>
-              </a:rPr>
-              <a:t>"Quitar acceso" la retira en cualquier momento.</a:t>
-            </a:r>
-            <a:endParaRPr lang="es-VE" sz="1150" dirty="0">
-              <a:solidFill>
-                <a:srgbClr val="15324D"/>
-              </a:solidFill>
-              <a:latin typeface="Calibri" pitchFamily="34" charset="0"/>
-              <a:ea typeface="Calibri" pitchFamily="34" charset="-122"/>
-              <a:cs typeface="Calibri" pitchFamily="34" charset="-120"/>
-            </a:endParaRPr>
-          </a:p>
-        </p:txBody>
-      </p:sp>
-      <p:sp>
-        <p:nvSpPr>
-          <p:cNvPr id="126" name="Shape"/>
-          <p:cNvSpPr/>
-          <p:nvPr/>
-        </p:nvSpPr>
-        <p:spPr>
-          <a:xfrm>
-            <a:off x="8366760" y="5378089"/>
-            <a:ext cx="3367735" cy="1005840"/>
-          </a:xfrm>
-          <a:prstGeom prst="roundRect">
-            <a:avLst>
-              <a:gd name="adj" fmla="val 7000"/>
-            </a:avLst>
-          </a:prstGeom>
-          <a:solidFill>
-            <a:srgbClr val="0E2438"/>
-          </a:solidFill>
-          <a:ln>
-            <a:noFill/>
-          </a:ln>
-        </p:spPr>
-        <p:txBody>
-          <a:bodyPr/>
-          <a:lstStyle/>
-          <a:p>
-            <a:endParaRPr lang="en-US"/>
-          </a:p>
-        </p:txBody>
-      </p:sp>
-      <p:sp>
-        <p:nvSpPr>
-          <p:cNvPr id="12" name="TextBox 11">
-            <a:extLst>
-              <a:ext uri="{FF2B5EF4-FFF2-40B4-BE49-F238E27FC236}">
-                <a16:creationId xmlns:a16="http://schemas.microsoft.com/office/drawing/2014/main" id="{357D9CA4-2CB4-9B30-C1D7-2A9FF29ED229}"/>
-              </a:ext>
-            </a:extLst>
-          </p:cNvPr>
-          <p:cNvSpPr txBox="1"/>
-          <p:nvPr/>
-        </p:nvSpPr>
-        <p:spPr>
-          <a:xfrm>
-            <a:off x="8569960" y="5517789"/>
-            <a:ext cx="1315568" cy="726440"/>
+          <p:cNvSpPr txBox="1"/>
+          <p:nvPr/>
+        </p:nvSpPr>
+        <p:spPr>
+          <a:xfrm>
+            <a:off x="8280400" y="4838699"/>
+            <a:ext cx="1460500" cy="1092200"/>
           </a:xfrm>
           <a:prstGeom prst="rect">
             <a:avLst/>
@@ -11850,7 +12066,7 @@
                 </a:solidFill>
                 <a:latin typeface="Calibri" panose="020F0502020204030204" pitchFamily="34" charset="0"/>
               </a:rPr>
-              <a:t>Cualquiera que escribía al bot veía la flota.</a:t>
+              <a:t>Cualquiera que escribía al bot veía la flota, sin registro.</a:t>
             </a:r>
             <a:endParaRPr lang="en-US" sz="1050">
               <a:solidFill>
@@ -11863,10 +12079,10 @@
       </p:sp>
       <p:sp>
         <p:nvSpPr>
-          <p:cNvPr id="13" name="TextBox 12">
+          <p:cNvPr id="33" name="TextBox 32">
             <a:extLst>
               <a:ext uri="{FF2B5EF4-FFF2-40B4-BE49-F238E27FC236}">
-                <a16:creationId xmlns:a16="http://schemas.microsoft.com/office/drawing/2014/main" id="{62F39220-3436-492F-9E99-852A68107E21}"/>
+                <a16:creationId xmlns:a16="http://schemas.microsoft.com/office/drawing/2014/main" id="{FDC8848D-4548-4382-A7AB-0C2CA9BED3B6}"/>
               </a:ext>
             </a:extLst>
           </p:cNvPr>
@@ -11875,8 +12091,8 @@
         </p:nvSpPr>
         <p:spPr>
           <a:xfrm>
-            <a:off x="10215728" y="5517789"/>
-            <a:ext cx="1315568" cy="726440"/>
+            <a:off x="10071100" y="4838699"/>
+            <a:ext cx="1460500" cy="1092200"/>
           </a:xfrm>
           <a:prstGeom prst="rect">
             <a:avLst/>
@@ -11912,7 +12128,7 @@
                 </a:solidFill>
                 <a:latin typeface="Calibri" panose="020F0502020204030204" pitchFamily="34" charset="0"/>
               </a:rPr>
-              <a:t>Solo recibe quien se aprueba.</a:t>
+              <a:t>Solo recibe quien se aprueba, y cada envío queda registrado.</a:t>
             </a:r>
             <a:endParaRPr lang="en-US" sz="1050" b="1">
               <a:solidFill>
@@ -11925,10 +12141,10 @@
       </p:sp>
       <p:sp>
         <p:nvSpPr>
-          <p:cNvPr id="14" name="TextBox 13">
+          <p:cNvPr id="34" name="TextBox 33">
             <a:extLst>
               <a:ext uri="{FF2B5EF4-FFF2-40B4-BE49-F238E27FC236}">
-                <a16:creationId xmlns:a16="http://schemas.microsoft.com/office/drawing/2014/main" id="{835719BA-21E1-9E75-AB17-9A254567B60D}"/>
+                <a16:creationId xmlns:a16="http://schemas.microsoft.com/office/drawing/2014/main" id="{27FE77FD-71D4-4277-40FD-2B53E166E540}"/>
               </a:ext>
             </a:extLst>
           </p:cNvPr>
@@ -11937,8 +12153,8 @@
         </p:nvSpPr>
         <p:spPr>
           <a:xfrm>
-            <a:off x="9885528" y="5517789"/>
-            <a:ext cx="208390" cy="726440"/>
+            <a:off x="9740900" y="4838699"/>
+            <a:ext cx="208390" cy="1092200"/>
           </a:xfrm>
           <a:prstGeom prst="rect">
             <a:avLst/>
@@ -11967,7 +12183,7 @@
     </p:spTree>
     <p:extLst>
       <p:ext uri="{BB962C8B-B14F-4D97-AF65-F5344CB8AC3E}">
-        <p14:creationId xmlns:p14="http://schemas.microsoft.com/office/powerpoint/2010/main" val="4123804503"/>
+        <p14:creationId xmlns:p14="http://schemas.microsoft.com/office/powerpoint/2010/main" val="816105077"/>
       </p:ext>
     </p:extLst>
   </p:cSld>
@@ -12038,7 +12254,7 @@
           <p:cNvPr id="3" name="Picture 2">
             <a:extLst>
               <a:ext uri="{FF2B5EF4-FFF2-40B4-BE49-F238E27FC236}">
-                <a16:creationId xmlns:a16="http://schemas.microsoft.com/office/drawing/2014/main" id="{1CED18CD-402F-9380-9789-2AC462056774}"/>
+                <a16:creationId xmlns:a16="http://schemas.microsoft.com/office/drawing/2014/main" id="{1F106445-5F49-CADC-2A70-C03B6CD444CA}"/>
               </a:ext>
             </a:extLst>
           </p:cNvPr>
@@ -12262,7 +12478,7 @@
           <p:cNvPr id="5" name="Picture 4">
             <a:extLst>
               <a:ext uri="{FF2B5EF4-FFF2-40B4-BE49-F238E27FC236}">
-                <a16:creationId xmlns:a16="http://schemas.microsoft.com/office/drawing/2014/main" id="{7A4DB836-232E-6BCE-C830-9687240C24B8}"/>
+                <a16:creationId xmlns:a16="http://schemas.microsoft.com/office/drawing/2014/main" id="{BCB4E113-17E1-A30D-6A50-4F0C6D180F30}"/>
               </a:ext>
             </a:extLst>
           </p:cNvPr>
@@ -12412,7 +12628,7 @@
           <p:cNvPr id="7" name="Picture 6">
             <a:extLst>
               <a:ext uri="{FF2B5EF4-FFF2-40B4-BE49-F238E27FC236}">
-                <a16:creationId xmlns:a16="http://schemas.microsoft.com/office/drawing/2014/main" id="{E5F7B1E2-75E7-C8B5-6E1E-F1956942BFC6}"/>
+                <a16:creationId xmlns:a16="http://schemas.microsoft.com/office/drawing/2014/main" id="{4463EFB3-CD62-9701-4B01-6CB3D04037DA}"/>
               </a:ext>
             </a:extLst>
           </p:cNvPr>
@@ -12580,7 +12796,7 @@
           <p:cNvPr id="9" name="Picture 8">
             <a:extLst>
               <a:ext uri="{FF2B5EF4-FFF2-40B4-BE49-F238E27FC236}">
-                <a16:creationId xmlns:a16="http://schemas.microsoft.com/office/drawing/2014/main" id="{FF3BDCF4-66FE-470F-B588-FA43749A3C4E}"/>
+                <a16:creationId xmlns:a16="http://schemas.microsoft.com/office/drawing/2014/main" id="{9F9C0EC2-DEA3-00D4-C215-AF7291590C83}"/>
               </a:ext>
             </a:extLst>
           </p:cNvPr>
@@ -12748,7 +12964,7 @@
           <p:cNvPr id="11" name="Picture 10">
             <a:extLst>
               <a:ext uri="{FF2B5EF4-FFF2-40B4-BE49-F238E27FC236}">
-                <a16:creationId xmlns:a16="http://schemas.microsoft.com/office/drawing/2014/main" id="{69CE4B2E-317C-2FDE-C017-43B3D32F1A82}"/>
+                <a16:creationId xmlns:a16="http://schemas.microsoft.com/office/drawing/2014/main" id="{820F449E-431D-E1B8-A71B-0792BD14CDE5}"/>
               </a:ext>
             </a:extLst>
           </p:cNvPr>
@@ -13285,7 +13501,7 @@
     </p:spTree>
     <p:extLst>
       <p:ext uri="{BB962C8B-B14F-4D97-AF65-F5344CB8AC3E}">
-        <p14:creationId xmlns:p14="http://schemas.microsoft.com/office/powerpoint/2010/main" val="3399651044"/>
+        <p14:creationId xmlns:p14="http://schemas.microsoft.com/office/powerpoint/2010/main" val="1186616385"/>
       </p:ext>
     </p:extLst>
   </p:cSld>

</xml_diff>

<commit_message>
Update the Tracker slides with the no-signal breakdown and internal-model download
Slide 13 (Estado de Flota) shows no-signal units summed by last status with
their probable reason; slide 18 (Reportes de Turno) mentions the new counts
and the internal-model Excel/PDF download.

Co-Authored-By: Claude Opus 5.5 <noreply@anthropic.com>
</commit_message>
<xml_diff>
--- a/informes/Proyectos_TI_Tracker.pptx
+++ b/informes/Proyectos_TI_Tracker.pptx
@@ -211,7 +211,7 @@
           <a:p>
             <a:fld id="{F361F212-34D7-4399-BCE0-06D8D6F55547}" type="datetimeFigureOut">
               <a:rPr lang="en-US" smtClean="0"/>
-              <a:t>9/24/2026</a:t>
+              <a:t>9/30/2026</a:t>
             </a:fld>
             <a:endParaRPr lang="en-US"/>
           </a:p>
@@ -4778,10 +4778,10 @@
       </p:sp>
       <p:pic>
         <p:nvPicPr>
-          <p:cNvPr id="5" name="Picture 4">
+          <p:cNvPr id="4" name="Picture 3">
             <a:extLst>
               <a:ext uri="{FF2B5EF4-FFF2-40B4-BE49-F238E27FC236}">
-                <a16:creationId xmlns:a16="http://schemas.microsoft.com/office/drawing/2014/main" id="{34E5B4CA-75EA-6C11-0CDA-B915E02F4274}"/>
+                <a16:creationId xmlns:a16="http://schemas.microsoft.com/office/drawing/2014/main" id="{A5C7DC18-510E-DE0F-046A-28BBA5F84E23}"/>
               </a:ext>
             </a:extLst>
           </p:cNvPr>
@@ -4792,7 +4792,7 @@
         </p:nvPicPr>
         <p:blipFill>
           <a:blip r:embed="rId3"/>
-          <a:srcRect r="68"/>
+          <a:srcRect r="50"/>
           <a:stretch>
             <a:fillRect/>
           </a:stretch>
@@ -4850,7 +4850,7 @@
                 <a:ea typeface="Calibri" pitchFamily="34" charset="-122"/>
                 <a:cs typeface="Calibri" pitchFamily="34" charset="-120"/>
               </a:rPr>
-              <a:t> — vista en vivo de las 75 unidades</a:t>
+              <a:t> — vista en vivo de las 76 unidades</a:t>
             </a:r>
             <a:endParaRPr lang="es-VE" sz="1050" spc="100" dirty="0">
               <a:solidFill>
@@ -5018,7 +5018,7 @@
                 <a:ea typeface="Calibri" pitchFamily="34" charset="-122"/>
                 <a:cs typeface="Calibri" pitchFamily="34" charset="-120"/>
               </a:rPr>
-              <a:t>Total, activas, estacionadas y sin señal, siempre arriba.</a:t>
+              <a:t>Activas + estacionadas = total; sin señal, desglosada.</a:t>
             </a:r>
             <a:endParaRPr lang="es-VE" sz="1000" dirty="0">
               <a:solidFill>
@@ -5264,10 +5264,10 @@
       </p:sp>
       <p:pic>
         <p:nvPicPr>
-          <p:cNvPr id="11" name="Picture 10">
+          <p:cNvPr id="8" name="Picture 7">
             <a:extLst>
               <a:ext uri="{FF2B5EF4-FFF2-40B4-BE49-F238E27FC236}">
-                <a16:creationId xmlns:a16="http://schemas.microsoft.com/office/drawing/2014/main" id="{C82A8217-7C37-9300-3F0B-DD81D0A2C9BD}"/>
+                <a16:creationId xmlns:a16="http://schemas.microsoft.com/office/drawing/2014/main" id="{4430B806-75B5-9343-2837-F9081FCBB5C6}"/>
               </a:ext>
             </a:extLst>
           </p:cNvPr>
@@ -5327,7 +5327,7 @@
                 <a:ea typeface="Cambria" pitchFamily="34" charset="-122"/>
                 <a:cs typeface="Cambria" pitchFamily="34" charset="-120"/>
               </a:rPr>
-              <a:t>Sincronizar ahora</a:t>
+              <a:t>Motivo probable</a:t>
             </a:r>
             <a:endParaRPr lang="es-VE" sz="1200" b="1" dirty="0">
               <a:solidFill>
@@ -5354,7 +5354,7 @@
                 <a:ea typeface="Calibri" pitchFamily="34" charset="-122"/>
                 <a:cs typeface="Calibri" pitchFamily="34" charset="-120"/>
               </a:rPr>
-              <a:t>Trae al instante la posición real del GPS.</a:t>
+              <a:t>Batería, alimentación, satélites o equipo apagado.</a:t>
             </a:r>
             <a:endParaRPr lang="es-VE" sz="1000" dirty="0">
               <a:solidFill>
@@ -5480,7 +5480,7 @@
                 <a:ea typeface="Calibri" pitchFamily="34" charset="-122"/>
                 <a:cs typeface="Calibri" pitchFamily="34" charset="-120"/>
               </a:rPr>
-              <a:t>Bloques desplegables: activas, estacionadas y sin señal reciente.</a:t>
+              <a:t>Las sin señal suman en su último estado (activa o estacionada).</a:t>
             </a:r>
             <a:endParaRPr lang="es-VE" sz="1150" dirty="0">
               <a:solidFill>
@@ -5514,7 +5514,7 @@
                 <a:ea typeface="Calibri" pitchFamily="34" charset="-122"/>
                 <a:cs typeface="Calibri" pitchFamily="34" charset="-120"/>
               </a:rPr>
-              <a:t>Ubicación clasificada: Base, Campo, Oficina u Otras.</a:t>
+              <a:t>De cada una: última conexión, tiempo sin señal y motivo.</a:t>
             </a:r>
             <a:endParaRPr lang="es-VE" sz="1150" dirty="0">
               <a:solidFill>
@@ -5674,7 +5674,7 @@
                 <a:ea typeface="Calibri" pitchFamily="34" charset="-122"/>
                 <a:cs typeface="Calibri" pitchFamily="34" charset="-120"/>
               </a:rPr>
-              <a:t>Las unidades sin señal quedan aparte, para revisarlas en sitio.</a:t>
+              <a:t>El motivo probable orienta la revisión en sitio.</a:t>
             </a:r>
             <a:endParaRPr lang="es-VE" sz="1150" dirty="0">
               <a:solidFill>
@@ -12017,68 +12017,6 @@
       </p:sp>
       <p:sp>
         <p:nvSpPr>
-          <p:cNvPr id="32" name="TextBox 31">
-            <a:extLst>
-              <a:ext uri="{FF2B5EF4-FFF2-40B4-BE49-F238E27FC236}">
-                <a16:creationId xmlns:a16="http://schemas.microsoft.com/office/drawing/2014/main" id="{A707F4AD-B049-2748-DD04-CC6F90A5004A}"/>
-              </a:ext>
-            </a:extLst>
-          </p:cNvPr>
-          <p:cNvSpPr txBox="1"/>
-          <p:nvPr/>
-        </p:nvSpPr>
-        <p:spPr>
-          <a:xfrm>
-            <a:off x="8280400" y="4838699"/>
-            <a:ext cx="1460500" cy="1092200"/>
-          </a:xfrm>
-          <a:prstGeom prst="rect">
-            <a:avLst/>
-          </a:prstGeom>
-          <a:noFill/>
-        </p:spPr>
-        <p:txBody>
-          <a:bodyPr vert="horz" wrap="square" lIns="0" tIns="0" rIns="0" bIns="0" rtlCol="0" anchor="ctr">
-            <a:noAutofit/>
-          </a:bodyPr>
-          <a:lstStyle/>
-          <a:p>
-            <a:r>
-              <a:rPr lang="es-ES" sz="900" b="1" spc="150">
-                <a:solidFill>
-                  <a:srgbClr val="94A3B8"/>
-                </a:solidFill>
-                <a:latin typeface="Calibri" panose="020F0502020204030204" pitchFamily="34" charset="0"/>
-              </a:rPr>
-              <a:t>ANTES</a:t>
-            </a:r>
-          </a:p>
-          <a:p>
-            <a:pPr>
-              <a:spcBef>
-                <a:spcPts val="300"/>
-              </a:spcBef>
-            </a:pPr>
-            <a:r>
-              <a:rPr lang="es-ES" sz="1050">
-                <a:solidFill>
-                  <a:srgbClr val="CBD5E1"/>
-                </a:solidFill>
-                <a:latin typeface="Calibri" panose="020F0502020204030204" pitchFamily="34" charset="0"/>
-              </a:rPr>
-              <a:t>Cualquiera que escribía al bot veía la flota, sin registro.</a:t>
-            </a:r>
-            <a:endParaRPr lang="en-US" sz="1050">
-              <a:solidFill>
-                <a:srgbClr val="CBD5E1"/>
-              </a:solidFill>
-              <a:latin typeface="Calibri" panose="020F0502020204030204" pitchFamily="34" charset="0"/>
-            </a:endParaRPr>
-          </a:p>
-        </p:txBody>
-      </p:sp>
-      <p:sp>
-        <p:nvSpPr>
           <p:cNvPr id="33" name="TextBox 32">
             <a:extLst>
               <a:ext uri="{FF2B5EF4-FFF2-40B4-BE49-F238E27FC236}">
@@ -12091,8 +12029,8 @@
         </p:nvSpPr>
         <p:spPr>
           <a:xfrm>
-            <a:off x="10071100" y="4838699"/>
-            <a:ext cx="1460500" cy="1092200"/>
+            <a:off x="8216900" y="4838699"/>
+            <a:ext cx="3314700" cy="1092200"/>
           </a:xfrm>
           <a:prstGeom prst="rect">
             <a:avLst/>
@@ -12106,13 +12044,13 @@
           <a:lstStyle/>
           <a:p>
             <a:r>
-              <a:rPr lang="es-ES" sz="900" b="1" spc="150">
+              <a:rPr lang="es-ES" sz="900" b="1" spc="150" dirty="0">
                 <a:solidFill>
                   <a:srgbClr val="E9C46A"/>
                 </a:solidFill>
                 <a:latin typeface="Calibri" panose="020F0502020204030204" pitchFamily="34" charset="0"/>
               </a:rPr>
-              <a:t>AHORA</a:t>
+              <a:t>IMPORTANTE:</a:t>
             </a:r>
           </a:p>
           <a:p>
@@ -12122,7 +12060,7 @@
               </a:spcBef>
             </a:pPr>
             <a:r>
-              <a:rPr lang="es-ES" sz="1050" b="1">
+              <a:rPr lang="es-ES" sz="1050" b="1" dirty="0">
                 <a:solidFill>
                   <a:srgbClr val="FFFFFF"/>
                 </a:solidFill>
@@ -12130,53 +12068,12 @@
               </a:rPr>
               <a:t>Solo recibe quien se aprueba, y cada envío queda registrado.</a:t>
             </a:r>
-            <a:endParaRPr lang="en-US" sz="1050" b="1">
+            <a:endParaRPr lang="en-US" sz="1050" b="1" dirty="0">
               <a:solidFill>
                 <a:srgbClr val="FFFFFF"/>
               </a:solidFill>
               <a:latin typeface="Calibri" panose="020F0502020204030204" pitchFamily="34" charset="0"/>
             </a:endParaRPr>
-          </a:p>
-        </p:txBody>
-      </p:sp>
-      <p:sp>
-        <p:nvSpPr>
-          <p:cNvPr id="34" name="TextBox 33">
-            <a:extLst>
-              <a:ext uri="{FF2B5EF4-FFF2-40B4-BE49-F238E27FC236}">
-                <a16:creationId xmlns:a16="http://schemas.microsoft.com/office/drawing/2014/main" id="{27FE77FD-71D4-4277-40FD-2B53E166E540}"/>
-              </a:ext>
-            </a:extLst>
-          </p:cNvPr>
-          <p:cNvSpPr txBox="1"/>
-          <p:nvPr/>
-        </p:nvSpPr>
-        <p:spPr>
-          <a:xfrm>
-            <a:off x="9740900" y="4838699"/>
-            <a:ext cx="208390" cy="1092200"/>
-          </a:xfrm>
-          <a:prstGeom prst="rect">
-            <a:avLst/>
-          </a:prstGeom>
-          <a:noFill/>
-        </p:spPr>
-        <p:txBody>
-          <a:bodyPr vert="horz" wrap="none" lIns="0" rIns="0" rtlCol="0" anchor="ctr">
-            <a:noAutofit/>
-          </a:bodyPr>
-          <a:lstStyle/>
-          <a:p>
-            <a:pPr algn="ctr"/>
-            <a:r>
-              <a:rPr lang="en-US" b="1">
-                <a:solidFill>
-                  <a:srgbClr val="E9C46A"/>
-                </a:solidFill>
-                <a:latin typeface="Calibri" panose="020F0502020204030204" pitchFamily="34" charset="0"/>
-              </a:rPr>
-              <a:t>→</a:t>
-            </a:r>
           </a:p>
         </p:txBody>
       </p:sp>
@@ -12475,10 +12372,10 @@
       </p:sp>
       <p:pic>
         <p:nvPicPr>
-          <p:cNvPr id="5" name="Picture 4">
+          <p:cNvPr id="4" name="Picture 3">
             <a:extLst>
               <a:ext uri="{FF2B5EF4-FFF2-40B4-BE49-F238E27FC236}">
-                <a16:creationId xmlns:a16="http://schemas.microsoft.com/office/drawing/2014/main" id="{BCB4E113-17E1-A30D-6A50-4F0C6D180F30}"/>
+                <a16:creationId xmlns:a16="http://schemas.microsoft.com/office/drawing/2014/main" id="{012A3540-BF33-E4AD-5D0B-7372B952B3B0}"/>
               </a:ext>
             </a:extLst>
           </p:cNvPr>
@@ -12489,7 +12386,7 @@
         </p:nvPicPr>
         <p:blipFill>
           <a:blip r:embed="rId3"/>
-          <a:srcRect r="68"/>
+          <a:srcRect r="50"/>
           <a:stretch>
             <a:fillRect/>
           </a:stretch>
@@ -13143,7 +13040,7 @@
                 <a:ea typeface="Calibri" pitchFamily="34" charset="-122"/>
                 <a:cs typeface="Calibri" pitchFamily="34" charset="-120"/>
               </a:rPr>
-              <a:t>Por fecha: total de unidades, activas, estacionadas y sin señal en el corte.</a:t>
+              <a:t>Por fecha: total, activas y estacionadas (suman el total) y cuántas sin señal.</a:t>
             </a:r>
             <a:endParaRPr lang="es-VE" sz="1150" dirty="0">
               <a:solidFill>
@@ -13379,7 +13276,7 @@
                 <a:ea typeface="Calibri" pitchFamily="34" charset="-122"/>
                 <a:cs typeface="Calibri" pitchFamily="34" charset="-120"/>
               </a:rPr>
-              <a:t>También sale en el formato del modelo interno.</a:t>
+              <a:t>También se descarga como el modelo interno, en Excel y PDF.</a:t>
             </a:r>
             <a:endParaRPr lang="es-VE" sz="1150" dirty="0">
               <a:solidFill>
@@ -13485,7 +13382,7 @@
                 <a:ea typeface="Calibri" pitchFamily="34" charset="-122"/>
                 <a:cs typeface="Calibri" pitchFamily="34" charset="-120"/>
               </a:rPr>
-              <a:t>La flota en cada cambio de turno, guardada por turno, sin armar reportes a mano.</a:t>
+              <a:t>La flota en cada cambio de turno, con las unidades sin señal y su motivo, sin armar reportes a mano.</a:t>
             </a:r>
             <a:endParaRPr lang="es-VE" sz="1050" dirty="0">
               <a:solidFill>

</xml_diff>